<commit_message>
feat: add uk give way
</commit_message>
<xml_diff>
--- a/docs/presentation/25027138 - Presentation.pptx
+++ b/docs/presentation/25027138 - Presentation.pptx
@@ -17,7 +17,7 @@
     <p:sldId id="327" r:id="rId7"/>
     <p:sldId id="320" r:id="rId8"/>
     <p:sldId id="321" r:id="rId9"/>
-    <p:sldId id="323" r:id="rId10"/>
+    <p:sldId id="328" r:id="rId10"/>
     <p:sldId id="324" r:id="rId11"/>
     <p:sldId id="325" r:id="rId12"/>
     <p:sldId id="326" r:id="rId13"/>
@@ -179,7 +179,7 @@
             <p14:sldId id="327"/>
             <p14:sldId id="320"/>
             <p14:sldId id="321"/>
-            <p14:sldId id="323"/>
+            <p14:sldId id="328"/>
             <p14:sldId id="324"/>
             <p14:sldId id="325"/>
             <p14:sldId id="326"/>
@@ -11539,10 +11539,10 @@
                         </a:defRPr>
                       </a:pPr>
                       <a:r>
-                        <a:rPr sz="1600"/>
-                        <a:t>Why it matters</a:t>
+                        <a:rPr lang="en-US" altLang="en-US" sz="1600"/>
+                        <a:t>Impact</a:t>
                       </a:r>
-                      <a:endParaRPr sz="1600"/>
+                      <a:endParaRPr lang="en-US" altLang="en-US" sz="1600"/>
                     </a:p>
                   </a:txBody>
                   <a:tcPr marL="36576" marR="36576" anchor="ctr">
@@ -11564,10 +11564,10 @@
                         </a:defRPr>
                       </a:pPr>
                       <a:r>
-                        <a:rPr sz="1600"/>
-                        <a:t>My response</a:t>
+                        <a:rPr lang="en-US" altLang="en-US" sz="1600"/>
+                        <a:t>Mitigation</a:t>
                       </a:r>
-                      <a:endParaRPr sz="1600"/>
+                      <a:endParaRPr lang="en-US" altLang="en-US" sz="1600"/>
                     </a:p>
                   </a:txBody>
                   <a:tcPr marL="36576" marR="36576" anchor="ctr">
@@ -11965,14 +11965,14 @@
               <a:rPr lang="en-US" altLang="en-US" sz="1800">
                 <a:latin typeface="UCL Sans" pitchFamily="2" charset="77"/>
               </a:rPr>
-              <a:t>The main research risk is not only whether the car can complete one scenario, </a:t>
+              <a:t>The main risk is interpretability: </a:t>
             </a:r>
             <a:endParaRPr lang="en-US" altLang="en-US" sz="1800">
               <a:latin typeface="UCL Sans" pitchFamily="2" charset="77"/>
             </a:endParaRPr>
           </a:p>
           <a:p>
-            <a:pPr algn="l">
+            <a:pPr indent="457200" algn="l">
               <a:defRPr sz="1500">
                 <a:solidFill>
                   <a:srgbClr val="111827"/>
@@ -11983,7 +11983,7 @@
               <a:rPr lang="en-US" altLang="en-US" sz="1800">
                 <a:latin typeface="UCL Sans" pitchFamily="2" charset="77"/>
               </a:rPr>
-              <a:t>but whether the method is reliable across different initial conditions.</a:t>
+              <a:t>I need to know not only whether the car succeeds, but why it succeeds or fails.</a:t>
             </a:r>
             <a:endParaRPr lang="en-US" altLang="en-US" sz="1800">
               <a:latin typeface="UCL Sans" pitchFamily="2" charset="77"/>
@@ -12059,6 +12059,43 @@
           </a:prstGeom>
         </p:spPr>
       </p:pic>
+      <p:sp>
+        <p:nvSpPr>
+          <p:cNvPr id="2" name="Text Box 1"/>
+          <p:cNvSpPr txBox="1"/>
+          <p:nvPr/>
+        </p:nvSpPr>
+        <p:spPr>
+          <a:xfrm>
+            <a:off x="5396865" y="4460875"/>
+            <a:ext cx="5413375" cy="1198880"/>
+          </a:xfrm>
+          <a:prstGeom prst="rect">
+            <a:avLst/>
+          </a:prstGeom>
+          <a:noFill/>
+        </p:spPr>
+        <p:txBody>
+          <a:bodyPr wrap="square" rtlCol="0" anchor="t">
+            <a:spAutoFit/>
+          </a:bodyPr>
+          <a:p>
+            <a:r>
+              <a:rPr lang="en-US" altLang="en-US" sz="7200" b="1">
+                <a:solidFill>
+                  <a:schemeClr val="accent2"/>
+                </a:solidFill>
+              </a:rPr>
+              <a:t>Thank you</a:t>
+            </a:r>
+            <a:endParaRPr lang="en-US" altLang="en-US" sz="7200" b="1">
+              <a:solidFill>
+                <a:schemeClr val="accent2"/>
+              </a:solidFill>
+            </a:endParaRPr>
+          </a:p>
+        </p:txBody>
+      </p:sp>
     </p:spTree>
   </p:cSld>
   <p:clrMapOvr>
@@ -12096,8 +12133,8 @@
         </p:nvSpPr>
         <p:spPr>
           <a:xfrm>
-            <a:off x="431800" y="409575"/>
-            <a:ext cx="11580495" cy="1009650"/>
+            <a:off x="50800" y="266065"/>
+            <a:ext cx="12091670" cy="1009650"/>
           </a:xfrm>
         </p:spPr>
         <p:txBody>
@@ -12114,9 +12151,15 @@
               <a:rPr lang="en-US" altLang="en-GB">
                 <a:latin typeface="UCL Sans SemiBold"/>
               </a:rPr>
-              <a:t>: Autonomous Driving</a:t>
-            </a:r>
-            <a:endParaRPr lang="en-US" altLang="en-GB">
+              <a:t>: </a:t>
+            </a:r>
+            <a:r>
+              <a:rPr lang="en-US" altLang="en-US">
+                <a:latin typeface="UCL Sans SemiBold"/>
+              </a:rPr>
+              <a:t>Motion Planning under Uncertainty</a:t>
+            </a:r>
+            <a:endParaRPr lang="en-US" altLang="en-US">
               <a:latin typeface="UCL Sans SemiBold"/>
             </a:endParaRPr>
           </a:p>
@@ -12197,7 +12240,23 @@
                   <a:srgbClr val="111827"/>
                 </a:solidFill>
               </a:rPr>
-              <a:t>This project focuses on motion planning:</a:t>
+              <a:t>This project focuses on motion planning under </a:t>
+            </a:r>
+            <a:r>
+              <a:rPr lang="en-US" altLang="en-US" sz="1800" b="1">
+                <a:solidFill>
+                  <a:srgbClr val="111827"/>
+                </a:solidFill>
+              </a:rPr>
+              <a:t>uncertainty</a:t>
+            </a:r>
+            <a:r>
+              <a:rPr lang="en-US" altLang="en-US" sz="1800">
+                <a:solidFill>
+                  <a:srgbClr val="111827"/>
+                </a:solidFill>
+              </a:rPr>
+              <a:t>:</a:t>
             </a:r>
             <a:endParaRPr lang="en-US" altLang="en-US" sz="1800">
               <a:solidFill>
@@ -12223,7 +12282,23 @@
                   <a:srgbClr val="111827"/>
                 </a:solidFill>
               </a:rPr>
-              <a:t>how the ego car decides a safe action when another vehicle may slow down, continue, or move differently.</a:t>
+              <a:t>how the ego car decides a safe action </a:t>
+            </a:r>
+            <a:r>
+              <a:rPr lang="en-US" altLang="en-US" sz="1800" b="1">
+                <a:solidFill>
+                  <a:srgbClr val="111827"/>
+                </a:solidFill>
+              </a:rPr>
+              <a:t>when another vehicle may slow down, continue, or move differently</a:t>
+            </a:r>
+            <a:r>
+              <a:rPr lang="en-US" altLang="en-US" sz="1800">
+                <a:solidFill>
+                  <a:srgbClr val="111827"/>
+                </a:solidFill>
+              </a:rPr>
+              <a:t>.</a:t>
             </a:r>
             <a:endParaRPr lang="en-US" altLang="en-US" sz="1800">
               <a:solidFill>
@@ -12791,16 +12866,16 @@
             <a:r>
               <a:rPr lang="en-US" altLang="en-US" sz="1800">
                 <a:solidFill>
-                  <a:srgbClr val="111827"/>
+                  <a:srgbClr val="FF0000"/>
                 </a:solidFill>
                 <a:latin typeface="UCL Sans" pitchFamily="2" charset="77"/>
                 <a:sym typeface="+mn-ea"/>
               </a:rPr>
-              <a:t>This is not general autonomous driving perception. </a:t>
+              <a:t>This is not about detecting objects.</a:t>
             </a:r>
             <a:endParaRPr lang="en-US" altLang="en-US" sz="1800">
               <a:solidFill>
-                <a:srgbClr val="111827"/>
+                <a:srgbClr val="FF0000"/>
               </a:solidFill>
               <a:latin typeface="UCL Sans" pitchFamily="2" charset="77"/>
               <a:sym typeface="+mn-ea"/>
@@ -12821,12 +12896,12 @@
             <a:r>
               <a:rPr lang="en-US" altLang="en-US" sz="1800">
                 <a:solidFill>
-                  <a:srgbClr val="111827"/>
+                  <a:srgbClr val="FF0000"/>
                 </a:solidFill>
                 <a:latin typeface="UCL Sans" pitchFamily="2" charset="77"/>
                 <a:sym typeface="+mn-ea"/>
               </a:rPr>
-              <a:t>It is about decision-making and control under uncertain future behaviour.</a:t>
+              <a:t>It is about turning uncertain predictions into safe driving decisions.</a:t>
             </a:r>
             <a:endParaRPr lang="en-US" altLang="en-US" sz="1800">
               <a:solidFill>
@@ -12847,7 +12922,7 @@
 </file>
 
 <file path=ppt/slides/slide3.xml><?xml version="1.0" encoding="utf-8"?>
-<p:sld xmlns:a="http://schemas.openxmlformats.org/drawingml/2006/main" xmlns:p="http://schemas.openxmlformats.org/presentationml/2006/main" xmlns:r="http://schemas.openxmlformats.org/officeDocument/2006/relationships">
+<p:sld xmlns:a="http://schemas.openxmlformats.org/drawingml/2006/main" xmlns:r="http://schemas.openxmlformats.org/officeDocument/2006/relationships" xmlns:p="http://schemas.openxmlformats.org/presentationml/2006/main">
   <p:cSld>
     <p:spTree>
       <p:nvGrpSpPr>
@@ -13020,22 +13095,8 @@
                   <a:srgbClr val="111827"/>
                 </a:solidFill>
               </a:rPr>
-              <a:t>The ego vehicle must make repeated decisions: observe the traffic, predict possible futures, plan an action, and update the plan.</a:t>
-            </a:r>
-            <a:endParaRPr lang="en-US" altLang="en-US" sz="1800">
-              <a:solidFill>
-                <a:srgbClr val="111827"/>
-              </a:solidFill>
-            </a:endParaRPr>
-          </a:p>
-          <a:p>
-            <a:pPr>
-              <a:defRPr sz="1500">
-                <a:solidFill>
-                  <a:srgbClr val="4B5563"/>
-                </a:solidFill>
-              </a:defRPr>
-            </a:pPr>
+              <a:t>The decision must be updated repeatedly as new observations arrive.</a:t>
+            </a:r>
             <a:endParaRPr lang="en-US" altLang="en-US" sz="1800">
               <a:solidFill>
                 <a:srgbClr val="111827"/>
@@ -13183,7 +13244,7 @@
           <p:nvPr/>
         </p:nvPicPr>
         <p:blipFill>
-          <a:blip r:embed="rId3"/>
+          <a:blip r:embed="rId1"/>
           <a:stretch>
             <a:fillRect/>
           </a:stretch>
@@ -13198,6 +13259,51 @@
           </a:prstGeom>
         </p:spPr>
       </p:pic>
+      <p:sp>
+        <p:nvSpPr>
+          <p:cNvPr id="4" name="Rectangle 3"/>
+          <p:cNvSpPr/>
+          <p:nvPr/>
+        </p:nvSpPr>
+        <p:spPr>
+          <a:xfrm>
+            <a:off x="8472170" y="2924810"/>
+            <a:ext cx="360045" cy="216535"/>
+          </a:xfrm>
+          <a:prstGeom prst="rect">
+            <a:avLst/>
+          </a:prstGeom>
+          <a:solidFill>
+            <a:schemeClr val="bg1"/>
+          </a:solidFill>
+          <a:ln>
+            <a:noFill/>
+          </a:ln>
+        </p:spPr>
+        <p:style>
+          <a:lnRef idx="2">
+            <a:schemeClr val="accent1">
+              <a:lumMod val="75000"/>
+            </a:schemeClr>
+          </a:lnRef>
+          <a:fillRef idx="1">
+            <a:schemeClr val="accent1"/>
+          </a:fillRef>
+          <a:effectRef idx="0">
+            <a:srgbClr val="FFFFFF"/>
+          </a:effectRef>
+          <a:fontRef idx="minor">
+            <a:schemeClr val="lt1"/>
+          </a:fontRef>
+        </p:style>
+        <p:txBody>
+          <a:bodyPr rtlCol="0" anchor="ctr"/>
+          <a:p>
+            <a:pPr algn="ctr"/>
+            <a:endParaRPr lang="en-US"/>
+          </a:p>
+        </p:txBody>
+      </p:sp>
     </p:spTree>
   </p:cSld>
   <p:clrMapOvr>
@@ -13271,13 +13377,16 @@
           <a:bodyPr/>
           <a:lstStyle/>
           <a:p>
+            <a:pPr indent="0">
+              <a:buFont typeface="Arial" panose="020B0604020202090204" pitchFamily="34" charset="0"/>
+            </a:pPr>
             <a:r>
               <a:rPr lang="en-US" altLang="en-US" dirty="0"/>
-              <a:t>At intersections, the target vehicle has several possible futures, and the ego vehicle does not know which one will happen. </a:t>
+              <a:t>If the planner trusts only one guessed target-vehicle trajector</a:t>
             </a:r>
             <a:r>
               <a:rPr lang="en-US" altLang="en-US" dirty="0"/>
-              <a:t>It may:</a:t>
+              <a:t>y, it may:</a:t>
             </a:r>
             <a:endParaRPr lang="en-US" altLang="en-US" dirty="0"/>
           </a:p>
@@ -13348,10 +13457,10 @@
         </p:nvGrpSpPr>
         <p:grpSpPr>
           <a:xfrm>
-            <a:off x="1148715" y="3321685"/>
-            <a:ext cx="9875520" cy="2103120"/>
+            <a:off x="1148715" y="3034665"/>
+            <a:ext cx="9875520" cy="2150110"/>
             <a:chOff x="1696" y="4666"/>
-            <a:chExt cx="15552" cy="3312"/>
+            <a:chExt cx="15552" cy="3386"/>
           </a:xfrm>
         </p:grpSpPr>
         <p:sp>
@@ -13951,8 +14060,8 @@
           </p:nvSpPr>
           <p:spPr>
             <a:xfrm>
-              <a:off x="11776" y="7546"/>
-              <a:ext cx="4896" cy="432"/>
+              <a:off x="13103" y="7472"/>
+              <a:ext cx="2242" cy="580"/>
             </a:xfrm>
             <a:prstGeom prst="rect">
               <a:avLst/>
@@ -13973,8 +14082,10 @@
                 </a:defRPr>
               </a:pPr>
               <a:r>
-                <a:t>More careful</a:t>
+                <a:rPr lang="en-US" altLang="en-US"/>
+                <a:t>Risk-aware</a:t>
               </a:r>
+              <a:endParaRPr lang="en-US" altLang="en-US"/>
             </a:p>
           </p:txBody>
         </p:sp>
@@ -13987,8 +14098,8 @@
         </p:nvSpPr>
         <p:spPr>
           <a:xfrm>
-            <a:off x="479425" y="5700395"/>
-            <a:ext cx="8580120" cy="645160"/>
+            <a:off x="352425" y="5446395"/>
+            <a:ext cx="11088370" cy="645160"/>
           </a:xfrm>
           <a:prstGeom prst="rect">
             <a:avLst/>
@@ -14028,7 +14139,7 @@
                 <a:latin typeface="UCL Sans" pitchFamily="2" charset="77"/>
                 <a:sym typeface="+mn-ea"/>
               </a:rPr>
-              <a:t>how can the car use multiple possible futures to choose a safe action?</a:t>
+              <a:t>how can the car use multiple predicted target-vehicle trajectories to choose a safe action?</a:t>
             </a:r>
             <a:endParaRPr lang="en-US" altLang="en-US" sz="1800" b="1" dirty="0">
               <a:solidFill>
@@ -14452,7 +14563,7 @@
         <p:spPr>
           <a:xfrm>
             <a:off x="422910" y="4798060"/>
-            <a:ext cx="11219180" cy="1153160"/>
+            <a:ext cx="11219180" cy="1314450"/>
           </a:xfrm>
           <a:prstGeom prst="rect">
             <a:avLst/>
@@ -14465,10 +14576,12 @@
           </a:bodyPr>
           <a:lstStyle/>
           <a:p>
-            <a:pPr marL="0">
+            <a:pPr marL="285750" indent="-285750">
               <a:spcAft>
                 <a:spcPts val="900"/>
               </a:spcAft>
+              <a:buFont typeface="Arial" panose="020B0604020202090204" pitchFamily="34" charset="0"/>
+              <a:buChar char="•"/>
               <a:defRPr sz="2200">
                 <a:solidFill>
                   <a:srgbClr val="111827"/>
@@ -14482,7 +14595,7 @@
                 </a:solidFill>
                 <a:latin typeface="UCL Sans" pitchFamily="2" charset="77"/>
               </a:rPr>
-              <a:t>If solved, autonomous vehicles could:</a:t>
+              <a:t>This is worth prioritising because prediction errors become real safety risks only when they affect the vehicle's action.</a:t>
             </a:r>
             <a:endParaRPr lang="en-US" altLang="en-US" sz="1800">
               <a:solidFill>
@@ -14492,12 +14605,12 @@
             </a:endParaRPr>
           </a:p>
           <a:p>
-            <a:pPr marL="342900" indent="-342900">
+            <a:pPr marL="285750" indent="-285750">
               <a:spcAft>
                 <a:spcPts val="900"/>
               </a:spcAft>
               <a:buFont typeface="Arial" panose="020B0604020202090204" pitchFamily="34" charset="0"/>
-              <a:buAutoNum type="arabicPeriod"/>
+              <a:buChar char="•"/>
               <a:defRPr sz="2200">
                 <a:solidFill>
                   <a:srgbClr val="111827"/>
@@ -14511,36 +14624,7 @@
                 </a:solidFill>
                 <a:latin typeface="UCL Sans" pitchFamily="2" charset="77"/>
               </a:rPr>
-              <a:t>cross complex intersections more reliably and avoid unsafe over-confident decisions;</a:t>
-            </a:r>
-            <a:endParaRPr lang="en-US" altLang="en-US" sz="1800">
-              <a:solidFill>
-                <a:schemeClr val="tx1"/>
-              </a:solidFill>
-              <a:latin typeface="UCL Sans" pitchFamily="2" charset="77"/>
-            </a:endParaRPr>
-          </a:p>
-          <a:p>
-            <a:pPr marL="342900" indent="-342900">
-              <a:spcAft>
-                <a:spcPts val="900"/>
-              </a:spcAft>
-              <a:buFont typeface="Arial" panose="020B0604020202090204" pitchFamily="34" charset="0"/>
-              <a:buAutoNum type="arabicPeriod"/>
-              <a:defRPr sz="2200">
-                <a:solidFill>
-                  <a:srgbClr val="111827"/>
-                </a:solidFill>
-              </a:defRPr>
-            </a:pPr>
-            <a:r>
-              <a:rPr lang="en-US" altLang="en-US" sz="1800">
-                <a:solidFill>
-                  <a:schemeClr val="tx1"/>
-                </a:solidFill>
-                <a:latin typeface="UCL Sans" pitchFamily="2" charset="77"/>
-              </a:rPr>
-              <a:t>reduce unnecessary stopping and provide smoother passenger experience.</a:t>
+              <a:t>If solved, the vehicle can cross complex intersections more reliably without simply becoming over-cautious.</a:t>
             </a:r>
             <a:endParaRPr lang="en-US" altLang="en-US" sz="1800">
               <a:solidFill>
@@ -14628,8 +14712,8 @@
         </p:nvSpPr>
         <p:spPr>
           <a:xfrm>
-            <a:off x="568960" y="1327785"/>
-            <a:ext cx="11155045" cy="4765040"/>
+            <a:off x="568960" y="5143500"/>
+            <a:ext cx="11155045" cy="1133475"/>
           </a:xfrm>
           <a:prstGeom prst="rect">
             <a:avLst/>
@@ -14655,290 +14739,844 @@
               </a:defRPr>
             </a:pPr>
             <a:r>
-              <a:rPr lang="en-US" altLang="en-US" sz="1800" b="1">
+              <a:rPr lang="en-US" altLang="en-US" sz="1800">
+                <a:solidFill>
+                  <a:schemeClr val="tx1"/>
+                </a:solidFill>
                 <a:latin typeface="UCL Sans" pitchFamily="2" charset="77"/>
               </a:rPr>
-              <a:t>MultiPath: </a:t>
-            </a:r>
-            <a:endParaRPr lang="en-US" altLang="en-US" sz="1800">
-              <a:latin typeface="UCL Sans" pitchFamily="2" charset="77"/>
-            </a:endParaRPr>
-          </a:p>
-          <a:p>
-            <a:pPr marL="742950" lvl="1" indent="-285750">
-              <a:spcAft>
-                <a:spcPts val="600"/>
-              </a:spcAft>
-              <a:buFont typeface="Arial" panose="020B0604020202090204" pitchFamily="34" charset="0"/>
-              <a:buChar char="•"/>
-              <a:defRPr sz="1700">
-                <a:solidFill>
-                  <a:srgbClr val="111827"/>
-                </a:solidFill>
-              </a:defRPr>
-            </a:pPr>
-            <a:r>
-              <a:rPr lang="en-US" altLang="en-US" sz="1800">
-                <a:latin typeface="UCL Sans" pitchFamily="2" charset="77"/>
-              </a:rPr>
-              <a:t>predicts several possible future paths with probabilities and uncertainty.</a:t>
-            </a:r>
-            <a:endParaRPr lang="en-US" altLang="en-US" sz="1800">
-              <a:latin typeface="UCL Sans" pitchFamily="2" charset="77"/>
-            </a:endParaRPr>
-          </a:p>
-          <a:p>
-            <a:pPr marL="742950" lvl="1" indent="-285750">
-              <a:spcAft>
-                <a:spcPts val="600"/>
-              </a:spcAft>
-              <a:buFont typeface="Arial" panose="020B0604020202090204" pitchFamily="34" charset="0"/>
-              <a:buChar char="•"/>
-              <a:defRPr sz="1700">
-                <a:solidFill>
-                  <a:srgbClr val="111827"/>
-                </a:solidFill>
-              </a:defRPr>
-            </a:pPr>
-            <a:r>
-              <a:rPr lang="en-US" altLang="en-US" sz="1800">
-                <a:latin typeface="UCL Sans" pitchFamily="2" charset="77"/>
-              </a:rPr>
-              <a:t>Limitation: prediction alone does not choose the ego vehicle's action.</a:t>
-            </a:r>
-            <a:endParaRPr lang="en-US" altLang="en-US" sz="1800">
-              <a:latin typeface="UCL Sans" pitchFamily="2" charset="77"/>
-            </a:endParaRPr>
-          </a:p>
-          <a:p>
-            <a:pPr lvl="1" indent="0">
-              <a:spcAft>
-                <a:spcPts val="600"/>
-              </a:spcAft>
-              <a:buFont typeface="Arial" panose="020B0604020202090204" pitchFamily="34" charset="0"/>
-              <a:buNone/>
-              <a:defRPr sz="1700">
-                <a:solidFill>
-                  <a:srgbClr val="111827"/>
-                </a:solidFill>
-              </a:defRPr>
-            </a:pPr>
-            <a:endParaRPr lang="en-US" altLang="en-US" sz="1800">
-              <a:latin typeface="UCL Sans" pitchFamily="2" charset="77"/>
-            </a:endParaRPr>
-          </a:p>
-          <a:p>
-            <a:pPr marL="0" lvl="0" indent="0">
-              <a:spcAft>
-                <a:spcPts val="600"/>
-              </a:spcAft>
-              <a:buFont typeface="Arial" panose="020B0604020202090204" pitchFamily="34" charset="0"/>
-              <a:buNone/>
-              <a:defRPr sz="1700">
-                <a:solidFill>
-                  <a:srgbClr val="111827"/>
-                </a:solidFill>
-              </a:defRPr>
-            </a:pPr>
-            <a:r>
-              <a:rPr lang="en-US" altLang="en-US" sz="1800">
-                <a:latin typeface="UCL Sans" pitchFamily="2" charset="77"/>
-              </a:rPr>
-              <a:t>SMPC </a:t>
-            </a:r>
-            <a:r>
-              <a:rPr lang="en-US" altLang="en-US" sz="1800">
-                <a:latin typeface="UCL Sans" pitchFamily="2" charset="77"/>
-                <a:sym typeface="+mn-ea"/>
-              </a:rPr>
-              <a:t>(Stochastic Model Predictive Control)</a:t>
-            </a:r>
-            <a:r>
-              <a:rPr lang="en-US" altLang="en-US" sz="1800">
-                <a:latin typeface="UCL Sans" pitchFamily="2" charset="77"/>
-              </a:rPr>
-              <a:t>:</a:t>
-            </a:r>
-            <a:endParaRPr lang="en-US" altLang="en-US" sz="1800">
-              <a:latin typeface="UCL Sans" pitchFamily="2" charset="77"/>
-            </a:endParaRPr>
-          </a:p>
-          <a:p>
-            <a:pPr marL="742950" lvl="1" indent="-285750">
-              <a:spcAft>
-                <a:spcPts val="600"/>
-              </a:spcAft>
-              <a:buFont typeface="Arial" panose="020B0604020202090204" pitchFamily="34" charset="0"/>
-              <a:buChar char="•"/>
-              <a:defRPr sz="1700">
-                <a:solidFill>
-                  <a:srgbClr val="111827"/>
-                </a:solidFill>
-              </a:defRPr>
-            </a:pPr>
-            <a:r>
-              <a:rPr lang="en-US" altLang="en-US" sz="1800">
-                <a:latin typeface="UCL Sans" pitchFamily="2" charset="77"/>
-              </a:rPr>
-              <a:t>plans safe actions under uncertainty using risk constraints.</a:t>
-            </a:r>
-            <a:endParaRPr lang="en-US" altLang="en-US" sz="1800">
-              <a:latin typeface="UCL Sans" pitchFamily="2" charset="77"/>
-            </a:endParaRPr>
-          </a:p>
-          <a:p>
-            <a:pPr marL="742950" lvl="1" indent="-285750">
-              <a:spcAft>
-                <a:spcPts val="600"/>
-              </a:spcAft>
-              <a:buFont typeface="Arial" panose="020B0604020202090204" pitchFamily="34" charset="0"/>
-              <a:buChar char="•"/>
-              <a:defRPr sz="1700">
-                <a:solidFill>
-                  <a:srgbClr val="111827"/>
-                </a:solidFill>
-              </a:defRPr>
-            </a:pPr>
-            <a:r>
-              <a:rPr lang="en-US" altLang="en-US" sz="1800">
-                <a:latin typeface="UCL Sans" pitchFamily="2" charset="77"/>
-              </a:rPr>
-              <a:t>Limitation: it may become conservative or infeasible when uncertainty is large.</a:t>
-            </a:r>
-            <a:endParaRPr lang="en-US" altLang="en-US" sz="1800">
-              <a:latin typeface="UCL Sans" pitchFamily="2" charset="77"/>
-            </a:endParaRPr>
-          </a:p>
-          <a:p>
-            <a:pPr marL="0" indent="0">
-              <a:spcAft>
-                <a:spcPts val="600"/>
-              </a:spcAft>
-              <a:buFont typeface="Arial" panose="020B0604020202090204" pitchFamily="34" charset="0"/>
-              <a:buNone/>
-              <a:defRPr sz="1700">
-                <a:solidFill>
-                  <a:srgbClr val="111827"/>
-                </a:solidFill>
-              </a:defRPr>
-            </a:pPr>
-            <a:endParaRPr lang="en-US" altLang="en-US" sz="1800">
-              <a:latin typeface="UCL Sans" pitchFamily="2" charset="77"/>
-            </a:endParaRPr>
-          </a:p>
-          <a:p>
-            <a:pPr marL="0" indent="0">
-              <a:spcAft>
-                <a:spcPts val="600"/>
-              </a:spcAft>
-              <a:buFont typeface="Arial" panose="020B0604020202090204" pitchFamily="34" charset="0"/>
-              <a:buNone/>
-              <a:defRPr sz="1700">
-                <a:solidFill>
-                  <a:srgbClr val="111827"/>
-                </a:solidFill>
-              </a:defRPr>
-            </a:pPr>
-            <a:r>
-              <a:rPr lang="en-US" altLang="en-US" sz="1800" b="1">
-                <a:latin typeface="UCL Sans" pitchFamily="2" charset="77"/>
-              </a:rPr>
-              <a:t>The remaining gap:</a:t>
-            </a:r>
-            <a:endParaRPr lang="en-US" altLang="en-US" sz="1800">
-              <a:latin typeface="UCL Sans" pitchFamily="2" charset="77"/>
-            </a:endParaRPr>
-          </a:p>
-          <a:p>
-            <a:pPr marL="742950" lvl="1" indent="-285750">
-              <a:spcAft>
-                <a:spcPts val="600"/>
-              </a:spcAft>
-              <a:buFont typeface="Arial" panose="020B0604020202090204" pitchFamily="34" charset="0"/>
-              <a:buChar char="•"/>
-              <a:defRPr sz="1700">
-                <a:solidFill>
-                  <a:srgbClr val="111827"/>
-                </a:solidFill>
-              </a:defRPr>
-            </a:pPr>
-            <a:r>
-              <a:rPr lang="en-US" altLang="en-US" sz="1800">
-                <a:latin typeface="UCL Sans" pitchFamily="2" charset="77"/>
-              </a:rPr>
-              <a:t>How can multimodal predictions be used safely and efficiently in closed-loop control?</a:t>
-            </a:r>
-            <a:endParaRPr lang="en-US" altLang="en-US" sz="1800">
-              <a:latin typeface="UCL Sans" pitchFamily="2" charset="77"/>
-            </a:endParaRPr>
-          </a:p>
-          <a:p>
-            <a:pPr lvl="1" indent="0">
-              <a:spcAft>
-                <a:spcPts val="600"/>
-              </a:spcAft>
-              <a:buFont typeface="Arial" panose="020B0604020202090204" pitchFamily="34" charset="0"/>
-              <a:buNone/>
-              <a:defRPr sz="1700">
-                <a:solidFill>
-                  <a:srgbClr val="111827"/>
-                </a:solidFill>
-              </a:defRPr>
-            </a:pPr>
-            <a:endParaRPr lang="en-US" altLang="en-US" sz="1800">
-              <a:latin typeface="UCL Sans" pitchFamily="2" charset="77"/>
-            </a:endParaRPr>
-          </a:p>
-          <a:p>
-            <a:pPr marL="0" indent="0">
-              <a:spcAft>
-                <a:spcPts val="600"/>
-              </a:spcAft>
-              <a:buFont typeface="Arial" panose="020B0604020202090204" pitchFamily="34" charset="0"/>
-              <a:buNone/>
-              <a:defRPr sz="1700">
-                <a:solidFill>
-                  <a:srgbClr val="111827"/>
-                </a:solidFill>
-              </a:defRPr>
-            </a:pPr>
-            <a:r>
-              <a:rPr lang="en-US" altLang="en-US" sz="1800">
-                <a:latin typeface="UCL Sans" pitchFamily="2" charset="77"/>
-              </a:rPr>
-              <a:t>My project: </a:t>
-            </a:r>
-            <a:endParaRPr lang="en-US" altLang="en-US" sz="1800">
-              <a:latin typeface="UCL Sans" pitchFamily="2" charset="77"/>
-            </a:endParaRPr>
-          </a:p>
-          <a:p>
-            <a:pPr marL="742950" lvl="1" indent="-285750">
-              <a:spcAft>
-                <a:spcPts val="600"/>
-              </a:spcAft>
-              <a:buFont typeface="Arial" panose="020B0604020202090204" pitchFamily="34" charset="0"/>
-              <a:buChar char="•"/>
-              <a:defRPr sz="1700">
-                <a:solidFill>
-                  <a:srgbClr val="111827"/>
-                </a:solidFill>
-              </a:defRPr>
-            </a:pPr>
-            <a:r>
-              <a:rPr lang="en-US" altLang="en-US" sz="1800">
-                <a:solidFill>
-                  <a:srgbClr val="FF0000"/>
-                </a:solidFill>
-                <a:latin typeface="UCL Sans" pitchFamily="2" charset="77"/>
-              </a:rPr>
-              <a:t>Produce and evaluate risk-aware SMPC in an intersection scenario with CARLA simulator.</a:t>
+              <a:t>Remaining Gap: </a:t>
             </a:r>
             <a:endParaRPr lang="en-US" altLang="en-US" sz="1800">
               <a:solidFill>
                 <a:srgbClr val="FF0000"/>
               </a:solidFill>
               <a:latin typeface="UCL Sans" pitchFamily="2" charset="77"/>
+            </a:endParaRPr>
+          </a:p>
+          <a:p>
+            <a:pPr marL="0" indent="457200">
+              <a:spcAft>
+                <a:spcPts val="600"/>
+              </a:spcAft>
+              <a:buFont typeface="Arial" panose="020B0604020202090204" pitchFamily="34" charset="0"/>
+              <a:buNone/>
+              <a:defRPr sz="1700">
+                <a:solidFill>
+                  <a:srgbClr val="111827"/>
+                </a:solidFill>
+              </a:defRPr>
+            </a:pPr>
+            <a:r>
+              <a:rPr lang="en-US" altLang="en-US" sz="1800" b="1">
+                <a:solidFill>
+                  <a:schemeClr val="accent2"/>
+                </a:solidFill>
+                <a:latin typeface="UCL Sans" pitchFamily="2" charset="77"/>
+              </a:rPr>
+              <a:t>we need a closed-loop planner that uses multimodal predictions while balancing safety, progress, feasibility, and comfort.</a:t>
+            </a:r>
+            <a:endParaRPr lang="en-US" altLang="en-US" sz="1800" b="1">
+              <a:solidFill>
+                <a:schemeClr val="accent2"/>
+              </a:solidFill>
+              <a:latin typeface="UCL Sans" pitchFamily="2" charset="77"/>
+            </a:endParaRPr>
+          </a:p>
+        </p:txBody>
+      </p:sp>
+      <p:graphicFrame>
+        <p:nvGraphicFramePr>
+          <p:cNvPr id="3" name="Table 2"/>
+          <p:cNvGraphicFramePr>
+            <a:graphicFrameLocks noGrp="1"/>
+          </p:cNvGraphicFramePr>
+          <p:nvPr/>
+        </p:nvGraphicFramePr>
+        <p:xfrm>
+          <a:off x="87630" y="1480185"/>
+          <a:ext cx="11943080" cy="3235960"/>
+        </p:xfrm>
+        <a:graphic>
+          <a:graphicData uri="http://schemas.openxmlformats.org/drawingml/2006/table">
+            <a:tbl>
+              <a:tblPr firstRow="1" bandRow="1">
+                <a:tableStyleId>{5C22544A-7EE6-4342-B048-85BDC9FD1C3A}</a:tableStyleId>
+              </a:tblPr>
+              <a:tblGrid>
+                <a:gridCol w="3550920"/>
+                <a:gridCol w="3592830"/>
+                <a:gridCol w="4799330"/>
+              </a:tblGrid>
+              <a:tr h="685165">
+                <a:tc>
+                  <a:txBody>
+                    <a:bodyPr/>
+                    <a:p>
+                      <a:pPr algn="ctr">
+                        <a:defRPr sz="1200" b="1">
+                          <a:solidFill>
+                            <a:srgbClr val="FFFFFF"/>
+                          </a:solidFill>
+                        </a:defRPr>
+                      </a:pPr>
+                      <a:r>
+                        <a:rPr lang="en-US" altLang="en-US" sz="1600"/>
+                        <a:t>Approach</a:t>
+                      </a:r>
+                      <a:endParaRPr lang="en-US" altLang="en-US" sz="1600"/>
+                    </a:p>
+                  </a:txBody>
+                  <a:tcPr marL="36576" marR="36576" anchor="ctr">
+                    <a:lnL>
+                      <a:noFill/>
+                    </a:lnL>
+                    <a:lnR w="12700">
+                      <a:solidFill>
+                        <a:schemeClr val="tx1"/>
+                      </a:solidFill>
+                      <a:prstDash val="solid"/>
+                    </a:lnR>
+                    <a:lnT>
+                      <a:noFill/>
+                    </a:lnT>
+                    <a:lnB w="12700">
+                      <a:solidFill>
+                        <a:schemeClr val="tx1"/>
+                      </a:solidFill>
+                      <a:prstDash val="solid"/>
+                    </a:lnB>
+                    <a:lnTlToBr>
+                      <a:noFill/>
+                    </a:lnTlToBr>
+                    <a:lnBlToTr>
+                      <a:noFill/>
+                    </a:lnBlToTr>
+                    <a:solidFill>
+                      <a:srgbClr val="002060"/>
+                    </a:solidFill>
+                  </a:tcPr>
+                </a:tc>
+                <a:tc>
+                  <a:txBody>
+                    <a:bodyPr/>
+                    <a:p>
+                      <a:pPr algn="ctr">
+                        <a:defRPr sz="1200" b="1">
+                          <a:solidFill>
+                            <a:srgbClr val="FFFFFF"/>
+                          </a:solidFill>
+                        </a:defRPr>
+                      </a:pPr>
+                      <a:r>
+                        <a:rPr lang="en-US" altLang="en-US" sz="1600"/>
+                        <a:t>Contribution</a:t>
+                      </a:r>
+                      <a:endParaRPr lang="en-US" altLang="en-US" sz="1600"/>
+                    </a:p>
+                  </a:txBody>
+                  <a:tcPr marL="36576" marR="36576" anchor="ctr">
+                    <a:lnL w="12700">
+                      <a:solidFill>
+                        <a:schemeClr val="tx1"/>
+                      </a:solidFill>
+                      <a:prstDash val="solid"/>
+                    </a:lnL>
+                    <a:lnR w="12700">
+                      <a:solidFill>
+                        <a:schemeClr val="tx1"/>
+                      </a:solidFill>
+                      <a:prstDash val="solid"/>
+                    </a:lnR>
+                    <a:lnB w="12700">
+                      <a:solidFill>
+                        <a:schemeClr val="tx1"/>
+                      </a:solidFill>
+                      <a:prstDash val="solid"/>
+                    </a:lnB>
+                    <a:solidFill>
+                      <a:srgbClr val="002060"/>
+                    </a:solidFill>
+                  </a:tcPr>
+                </a:tc>
+                <a:tc>
+                  <a:txBody>
+                    <a:bodyPr/>
+                    <a:p>
+                      <a:pPr algn="ctr">
+                        <a:defRPr sz="1200" b="1">
+                          <a:solidFill>
+                            <a:srgbClr val="FFFFFF"/>
+                          </a:solidFill>
+                        </a:defRPr>
+                      </a:pPr>
+                      <a:r>
+                        <a:rPr lang="en-US" altLang="en-US" sz="1600"/>
+                        <a:t>Remaining limitation</a:t>
+                      </a:r>
+                      <a:endParaRPr lang="en-US" altLang="en-US" sz="1600"/>
+                    </a:p>
+                  </a:txBody>
+                  <a:tcPr marL="36576" marR="36576" anchor="ctr">
+                    <a:lnL w="12700">
+                      <a:solidFill>
+                        <a:schemeClr val="tx1"/>
+                      </a:solidFill>
+                      <a:prstDash val="solid"/>
+                    </a:lnL>
+                    <a:lnB w="12700">
+                      <a:solidFill>
+                        <a:schemeClr val="tx1"/>
+                      </a:solidFill>
+                      <a:prstDash val="solid"/>
+                    </a:lnB>
+                    <a:solidFill>
+                      <a:srgbClr val="002060"/>
+                    </a:solidFill>
+                  </a:tcPr>
+                </a:tc>
+              </a:tr>
+              <a:tr h="685165">
+                <a:tc>
+                  <a:txBody>
+                    <a:bodyPr/>
+                    <a:lstStyle/>
+                    <a:p>
+                      <a:pPr algn="ctr">
+                        <a:defRPr sz="1200">
+                          <a:solidFill>
+                            <a:srgbClr val="111827"/>
+                          </a:solidFill>
+                        </a:defRPr>
+                      </a:pPr>
+                      <a:r>
+                        <a:rPr lang="en-US" altLang="en-US" sz="1600" b="1"/>
+                        <a:t>Multimodal prediction, </a:t>
+                      </a:r>
+                      <a:endParaRPr lang="en-US" altLang="en-US" sz="1600" b="1"/>
+                    </a:p>
+                    <a:p>
+                      <a:pPr algn="ctr">
+                        <a:defRPr sz="1200">
+                          <a:solidFill>
+                            <a:srgbClr val="111827"/>
+                          </a:solidFill>
+                        </a:defRPr>
+                      </a:pPr>
+                      <a:r>
+                        <a:rPr lang="en-US" altLang="en-US" sz="1600" b="1"/>
+                        <a:t>e.g. MultiPath</a:t>
+                      </a:r>
+                      <a:endParaRPr lang="en-US" altLang="en-US" sz="1600" b="1"/>
+                    </a:p>
+                  </a:txBody>
+                  <a:tcPr marL="36576" marR="36576" anchor="ctr">
+                    <a:lnL>
+                      <a:noFill/>
+                    </a:lnL>
+                    <a:lnR w="12700">
+                      <a:solidFill>
+                        <a:schemeClr val="tx1"/>
+                      </a:solidFill>
+                      <a:prstDash val="solid"/>
+                    </a:lnR>
+                    <a:lnT w="12700">
+                      <a:solidFill>
+                        <a:schemeClr val="tx1"/>
+                      </a:solidFill>
+                      <a:prstDash val="solid"/>
+                    </a:lnT>
+                    <a:lnB w="12700">
+                      <a:solidFill>
+                        <a:schemeClr val="tx1"/>
+                      </a:solidFill>
+                      <a:prstDash val="solid"/>
+                    </a:lnB>
+                    <a:lnTlToBr>
+                      <a:noFill/>
+                    </a:lnTlToBr>
+                    <a:lnBlToTr>
+                      <a:noFill/>
+                    </a:lnBlToTr>
+                    <a:solidFill>
+                      <a:srgbClr val="FFFFFF"/>
+                    </a:solidFill>
+                  </a:tcPr>
+                </a:tc>
+                <a:tc>
+                  <a:txBody>
+                    <a:bodyPr/>
+                    <a:lstStyle/>
+                    <a:p>
+                      <a:pPr algn="ctr">
+                        <a:defRPr sz="1200">
+                          <a:solidFill>
+                            <a:srgbClr val="111827"/>
+                          </a:solidFill>
+                        </a:defRPr>
+                      </a:pPr>
+                      <a:r>
+                        <a:rPr lang="en-US" altLang="en-US" sz="1600" b="0"/>
+                        <a:t>predicts several possible trajectories</a:t>
+                      </a:r>
+                      <a:endParaRPr lang="en-US" altLang="en-US" sz="1600" b="0"/>
+                    </a:p>
+                  </a:txBody>
+                  <a:tcPr marL="36576" marR="36576" anchor="ctr">
+                    <a:lnL w="12700">
+                      <a:solidFill>
+                        <a:schemeClr val="tx1"/>
+                      </a:solidFill>
+                      <a:prstDash val="solid"/>
+                    </a:lnL>
+                    <a:lnR w="12700">
+                      <a:solidFill>
+                        <a:schemeClr val="tx1"/>
+                      </a:solidFill>
+                      <a:prstDash val="solid"/>
+                    </a:lnR>
+                    <a:lnT w="12700">
+                      <a:solidFill>
+                        <a:schemeClr val="tx1"/>
+                      </a:solidFill>
+                      <a:prstDash val="solid"/>
+                    </a:lnT>
+                    <a:lnB w="12700">
+                      <a:solidFill>
+                        <a:schemeClr val="tx1"/>
+                      </a:solidFill>
+                      <a:prstDash val="solid"/>
+                    </a:lnB>
+                    <a:solidFill>
+                      <a:srgbClr val="FFFFFF"/>
+                    </a:solidFill>
+                  </a:tcPr>
+                </a:tc>
+                <a:tc>
+                  <a:txBody>
+                    <a:bodyPr/>
+                    <a:lstStyle/>
+                    <a:p>
+                      <a:pPr algn="ctr">
+                        <a:defRPr sz="1200">
+                          <a:solidFill>
+                            <a:srgbClr val="111827"/>
+                          </a:solidFill>
+                        </a:defRPr>
+                      </a:pPr>
+                      <a:r>
+                        <a:rPr lang="en-US" altLang="en-US" sz="1600" b="0"/>
+                        <a:t>does not choose the ego action</a:t>
+                      </a:r>
+                      <a:endParaRPr lang="en-US" altLang="en-US" sz="1600" b="0"/>
+                    </a:p>
+                  </a:txBody>
+                  <a:tcPr marL="36576" marR="36576" anchor="ctr">
+                    <a:lnL w="12700">
+                      <a:solidFill>
+                        <a:schemeClr val="tx1"/>
+                      </a:solidFill>
+                      <a:prstDash val="solid"/>
+                    </a:lnL>
+                    <a:lnT w="12700">
+                      <a:solidFill>
+                        <a:schemeClr val="tx1"/>
+                      </a:solidFill>
+                      <a:prstDash val="solid"/>
+                    </a:lnT>
+                    <a:lnB w="12700">
+                      <a:solidFill>
+                        <a:schemeClr val="tx1"/>
+                      </a:solidFill>
+                      <a:prstDash val="solid"/>
+                    </a:lnB>
+                    <a:solidFill>
+                      <a:srgbClr val="FFFFFF"/>
+                    </a:solidFill>
+                  </a:tcPr>
+                </a:tc>
+              </a:tr>
+              <a:tr h="603885">
+                <a:tc>
+                  <a:txBody>
+                    <a:bodyPr/>
+                    <a:lstStyle/>
+                    <a:p>
+                      <a:pPr algn="ctr">
+                        <a:defRPr sz="1200">
+                          <a:solidFill>
+                            <a:srgbClr val="111827"/>
+                          </a:solidFill>
+                        </a:defRPr>
+                      </a:pPr>
+                      <a:r>
+                        <a:rPr lang="en-US" altLang="en-US" sz="1600" b="1">
+                          <a:sym typeface="+mn-ea"/>
+                        </a:rPr>
+                        <a:t>Learning-based planners</a:t>
+                      </a:r>
+                      <a:endParaRPr lang="en-US" altLang="en-US" sz="1600" b="1"/>
+                    </a:p>
+                  </a:txBody>
+                  <a:tcPr marL="36576" marR="36576" anchor="ctr">
+                    <a:lnR w="12700">
+                      <a:solidFill>
+                        <a:schemeClr val="tx1"/>
+                      </a:solidFill>
+                      <a:prstDash val="solid"/>
+                    </a:lnR>
+                    <a:lnT w="12700">
+                      <a:solidFill>
+                        <a:schemeClr val="tx1"/>
+                      </a:solidFill>
+                      <a:prstDash val="solid"/>
+                    </a:lnT>
+                    <a:lnB w="12700">
+                      <a:solidFill>
+                        <a:schemeClr val="tx1"/>
+                      </a:solidFill>
+                      <a:prstDash val="solid"/>
+                    </a:lnB>
+                    <a:solidFill>
+                      <a:srgbClr val="F3F4F6"/>
+                    </a:solidFill>
+                  </a:tcPr>
+                </a:tc>
+                <a:tc>
+                  <a:txBody>
+                    <a:bodyPr/>
+                    <a:lstStyle/>
+                    <a:p>
+                      <a:pPr algn="ctr">
+                        <a:defRPr sz="1200">
+                          <a:solidFill>
+                            <a:srgbClr val="111827"/>
+                          </a:solidFill>
+                        </a:defRPr>
+                      </a:pPr>
+                      <a:r>
+                        <a:rPr lang="en-US" altLang="en-US" sz="1600">
+                          <a:sym typeface="+mn-ea"/>
+                        </a:rPr>
+                        <a:t>can learn complex behaviour</a:t>
+                      </a:r>
+                      <a:endParaRPr lang="en-US" altLang="en-US" sz="1600"/>
+                    </a:p>
+                  </a:txBody>
+                  <a:tcPr marL="36576" marR="36576" anchor="ctr">
+                    <a:lnL w="12700">
+                      <a:solidFill>
+                        <a:schemeClr val="tx1"/>
+                      </a:solidFill>
+                      <a:prstDash val="solid"/>
+                    </a:lnL>
+                    <a:lnR w="12700">
+                      <a:solidFill>
+                        <a:schemeClr val="tx1"/>
+                      </a:solidFill>
+                      <a:prstDash val="solid"/>
+                    </a:lnR>
+                    <a:lnT w="12700">
+                      <a:solidFill>
+                        <a:schemeClr val="tx1"/>
+                      </a:solidFill>
+                      <a:prstDash val="solid"/>
+                    </a:lnT>
+                    <a:lnB w="12700">
+                      <a:solidFill>
+                        <a:schemeClr val="tx1"/>
+                      </a:solidFill>
+                      <a:prstDash val="solid"/>
+                    </a:lnB>
+                    <a:solidFill>
+                      <a:srgbClr val="F3F4F6"/>
+                    </a:solidFill>
+                  </a:tcPr>
+                </a:tc>
+                <a:tc>
+                  <a:txBody>
+                    <a:bodyPr/>
+                    <a:lstStyle/>
+                    <a:p>
+                      <a:pPr algn="ctr">
+                        <a:defRPr sz="1200">
+                          <a:solidFill>
+                            <a:srgbClr val="111827"/>
+                          </a:solidFill>
+                        </a:defRPr>
+                      </a:pPr>
+                      <a:r>
+                        <a:rPr lang="en-US" altLang="en-US" sz="1600">
+                          <a:sym typeface="+mn-ea"/>
+                        </a:rPr>
+                        <a:t>hard to guarantee safety and interpret failure</a:t>
+                      </a:r>
+                      <a:r>
+                        <a:rPr lang="en-US" altLang="en-US" sz="1600"/>
+                        <a:t>s</a:t>
+                      </a:r>
+                      <a:endParaRPr lang="en-US" altLang="en-US" sz="1600"/>
+                    </a:p>
+                  </a:txBody>
+                  <a:tcPr marL="36576" marR="36576" anchor="ctr">
+                    <a:lnL w="12700">
+                      <a:solidFill>
+                        <a:schemeClr val="tx1"/>
+                      </a:solidFill>
+                      <a:prstDash val="solid"/>
+                    </a:lnL>
+                    <a:lnT w="12700">
+                      <a:solidFill>
+                        <a:schemeClr val="tx1"/>
+                      </a:solidFill>
+                      <a:prstDash val="solid"/>
+                    </a:lnT>
+                    <a:lnB w="12700">
+                      <a:solidFill>
+                        <a:schemeClr val="tx1"/>
+                      </a:solidFill>
+                      <a:prstDash val="solid"/>
+                    </a:lnB>
+                    <a:solidFill>
+                      <a:srgbClr val="F3F4F6"/>
+                    </a:solidFill>
+                  </a:tcPr>
+                </a:tc>
+              </a:tr>
+              <a:tr h="605790">
+                <a:tc>
+                  <a:txBody>
+                    <a:bodyPr/>
+                    <a:lstStyle/>
+                    <a:p>
+                      <a:pPr algn="ctr">
+                        <a:defRPr sz="1200">
+                          <a:solidFill>
+                            <a:srgbClr val="111827"/>
+                          </a:solidFill>
+                        </a:defRPr>
+                      </a:pPr>
+                      <a:r>
+                        <a:rPr lang="en-US" altLang="en-US" sz="1600" b="1"/>
+                        <a:t>Rule-based safety methods</a:t>
+                      </a:r>
+                      <a:endParaRPr lang="en-US" altLang="en-US" sz="1600" b="1"/>
+                    </a:p>
+                  </a:txBody>
+                  <a:tcPr marL="36576" marR="36576" anchor="ctr">
+                    <a:lnR w="12700">
+                      <a:solidFill>
+                        <a:schemeClr val="tx1"/>
+                      </a:solidFill>
+                      <a:prstDash val="solid"/>
+                    </a:lnR>
+                    <a:lnT w="12700">
+                      <a:solidFill>
+                        <a:schemeClr val="tx1"/>
+                      </a:solidFill>
+                      <a:prstDash val="solid"/>
+                    </a:lnT>
+                    <a:lnB w="12700">
+                      <a:solidFill>
+                        <a:schemeClr val="tx1"/>
+                      </a:solidFill>
+                      <a:prstDash val="solid"/>
+                    </a:lnB>
+                    <a:solidFill>
+                      <a:srgbClr val="FFFFFF"/>
+                    </a:solidFill>
+                  </a:tcPr>
+                </a:tc>
+                <a:tc>
+                  <a:txBody>
+                    <a:bodyPr/>
+                    <a:lstStyle/>
+                    <a:p>
+                      <a:pPr algn="ctr">
+                        <a:defRPr sz="1200">
+                          <a:solidFill>
+                            <a:srgbClr val="111827"/>
+                          </a:solidFill>
+                        </a:defRPr>
+                      </a:pPr>
+                      <a:r>
+                        <a:rPr lang="en-US" altLang="en-US" sz="1600"/>
+                        <a:t>provide simple safety guarantees</a:t>
+                      </a:r>
+                      <a:endParaRPr lang="en-US" altLang="en-US" sz="1600"/>
+                    </a:p>
+                  </a:txBody>
+                  <a:tcPr marL="36576" marR="36576" anchor="ctr">
+                    <a:lnL w="12700">
+                      <a:solidFill>
+                        <a:schemeClr val="tx1"/>
+                      </a:solidFill>
+                      <a:prstDash val="solid"/>
+                    </a:lnL>
+                    <a:lnR w="12700">
+                      <a:solidFill>
+                        <a:schemeClr val="tx1"/>
+                      </a:solidFill>
+                      <a:prstDash val="solid"/>
+                    </a:lnR>
+                    <a:lnT w="12700">
+                      <a:solidFill>
+                        <a:schemeClr val="tx1"/>
+                      </a:solidFill>
+                      <a:prstDash val="solid"/>
+                    </a:lnT>
+                    <a:lnB w="12700">
+                      <a:solidFill>
+                        <a:schemeClr val="tx1"/>
+                      </a:solidFill>
+                      <a:prstDash val="solid"/>
+                    </a:lnB>
+                    <a:solidFill>
+                      <a:srgbClr val="FFFFFF"/>
+                    </a:solidFill>
+                  </a:tcPr>
+                </a:tc>
+                <a:tc>
+                  <a:txBody>
+                    <a:bodyPr/>
+                    <a:lstStyle/>
+                    <a:p>
+                      <a:pPr algn="ctr">
+                        <a:defRPr sz="1200">
+                          <a:solidFill>
+                            <a:srgbClr val="111827"/>
+                          </a:solidFill>
+                        </a:defRPr>
+                      </a:pPr>
+                      <a:r>
+                        <a:rPr lang="en-US" altLang="en-US" sz="1600"/>
+                        <a:t>may be too rigid in interactive scenarios</a:t>
+                      </a:r>
+                      <a:endParaRPr lang="en-US" altLang="en-US" sz="1600"/>
+                    </a:p>
+                  </a:txBody>
+                  <a:tcPr marL="36576" marR="36576" anchor="ctr">
+                    <a:lnL w="12700">
+                      <a:solidFill>
+                        <a:schemeClr val="tx1"/>
+                      </a:solidFill>
+                      <a:prstDash val="solid"/>
+                    </a:lnL>
+                    <a:lnT w="12700">
+                      <a:solidFill>
+                        <a:schemeClr val="tx1"/>
+                      </a:solidFill>
+                      <a:prstDash val="solid"/>
+                    </a:lnT>
+                    <a:lnB w="12700">
+                      <a:solidFill>
+                        <a:schemeClr val="tx1"/>
+                      </a:solidFill>
+                      <a:prstDash val="solid"/>
+                    </a:lnB>
+                    <a:solidFill>
+                      <a:srgbClr val="FFFFFF"/>
+                    </a:solidFill>
+                  </a:tcPr>
+                </a:tc>
+              </a:tr>
+              <a:tr h="655955">
+                <a:tc>
+                  <a:txBody>
+                    <a:bodyPr/>
+                    <a:lstStyle/>
+                    <a:p>
+                      <a:pPr algn="ctr">
+                        <a:defRPr sz="1200">
+                          <a:solidFill>
+                            <a:srgbClr val="111827"/>
+                          </a:solidFill>
+                        </a:defRPr>
+                      </a:pPr>
+                      <a:r>
+                        <a:rPr lang="en-US" altLang="en-US" sz="1600" b="1">
+                          <a:solidFill>
+                            <a:srgbClr val="FF0000"/>
+                          </a:solidFill>
+                          <a:sym typeface="+mn-ea"/>
+                        </a:rPr>
+                        <a:t>Risk-aware SMPC</a:t>
+                      </a:r>
+                      <a:endParaRPr lang="en-US" altLang="en-US" sz="1600" b="1">
+                        <a:solidFill>
+                          <a:srgbClr val="FF0000"/>
+                        </a:solidFill>
+                        <a:sym typeface="+mn-ea"/>
+                      </a:endParaRPr>
+                    </a:p>
+                  </a:txBody>
+                  <a:tcPr marL="36576" marR="36576" anchor="ctr">
+                    <a:lnR w="12700">
+                      <a:solidFill>
+                        <a:schemeClr val="tx1"/>
+                      </a:solidFill>
+                      <a:prstDash val="solid"/>
+                    </a:lnR>
+                    <a:lnT w="12700">
+                      <a:solidFill>
+                        <a:schemeClr val="tx1"/>
+                      </a:solidFill>
+                      <a:prstDash val="solid"/>
+                    </a:lnT>
+                    <a:solidFill>
+                      <a:srgbClr val="F3F4F6"/>
+                    </a:solidFill>
+                  </a:tcPr>
+                </a:tc>
+                <a:tc>
+                  <a:txBody>
+                    <a:bodyPr/>
+                    <a:lstStyle/>
+                    <a:p>
+                      <a:pPr algn="ctr">
+                        <a:defRPr sz="1200">
+                          <a:solidFill>
+                            <a:srgbClr val="111827"/>
+                          </a:solidFill>
+                        </a:defRPr>
+                      </a:pPr>
+                      <a:r>
+                        <a:rPr lang="en-US" altLang="en-US" sz="1600" b="1">
+                          <a:solidFill>
+                            <a:srgbClr val="FF0000"/>
+                          </a:solidFill>
+                          <a:sym typeface="+mn-ea"/>
+                        </a:rPr>
+                        <a:t>plans under uncertainty</a:t>
+                      </a:r>
+                      <a:endParaRPr lang="en-US" altLang="en-US" sz="1600" b="1">
+                        <a:solidFill>
+                          <a:srgbClr val="FF0000"/>
+                        </a:solidFill>
+                        <a:sym typeface="+mn-ea"/>
+                      </a:endParaRPr>
+                    </a:p>
+                  </a:txBody>
+                  <a:tcPr marL="36576" marR="36576" anchor="ctr">
+                    <a:lnL w="12700">
+                      <a:solidFill>
+                        <a:schemeClr val="tx1"/>
+                      </a:solidFill>
+                      <a:prstDash val="solid"/>
+                    </a:lnL>
+                    <a:lnR w="12700">
+                      <a:solidFill>
+                        <a:schemeClr val="tx1"/>
+                      </a:solidFill>
+                      <a:prstDash val="solid"/>
+                    </a:lnR>
+                    <a:lnT w="12700">
+                      <a:solidFill>
+                        <a:schemeClr val="tx1"/>
+                      </a:solidFill>
+                      <a:prstDash val="solid"/>
+                    </a:lnT>
+                    <a:solidFill>
+                      <a:srgbClr val="F3F4F6"/>
+                    </a:solidFill>
+                  </a:tcPr>
+                </a:tc>
+                <a:tc>
+                  <a:txBody>
+                    <a:bodyPr/>
+                    <a:lstStyle/>
+                    <a:p>
+                      <a:pPr algn="ctr">
+                        <a:defRPr sz="1200">
+                          <a:solidFill>
+                            <a:srgbClr val="111827"/>
+                          </a:solidFill>
+                        </a:defRPr>
+                      </a:pPr>
+                      <a:r>
+                        <a:rPr lang="en-US" altLang="en-US" sz="1600" b="1">
+                          <a:solidFill>
+                            <a:srgbClr val="FF0000"/>
+                          </a:solidFill>
+                          <a:sym typeface="+mn-ea"/>
+                        </a:rPr>
+                        <a:t>can become conservative or infeasible</a:t>
+                      </a:r>
+                      <a:r>
+                        <a:rPr lang="en-US" altLang="en-US" sz="1600" b="1">
+                          <a:solidFill>
+                            <a:srgbClr val="FF0000"/>
+                          </a:solidFill>
+                        </a:rPr>
+                        <a:t> </a:t>
+                      </a:r>
+                      <a:endParaRPr lang="en-US" altLang="en-US" sz="1600" b="1">
+                        <a:solidFill>
+                          <a:srgbClr val="FF0000"/>
+                        </a:solidFill>
+                      </a:endParaRPr>
+                    </a:p>
+                  </a:txBody>
+                  <a:tcPr marL="36576" marR="36576" anchor="ctr">
+                    <a:lnL w="12700">
+                      <a:solidFill>
+                        <a:schemeClr val="tx1"/>
+                      </a:solidFill>
+                      <a:prstDash val="solid"/>
+                    </a:lnL>
+                    <a:lnT w="12700">
+                      <a:solidFill>
+                        <a:schemeClr val="tx1"/>
+                      </a:solidFill>
+                      <a:prstDash val="solid"/>
+                    </a:lnT>
+                    <a:solidFill>
+                      <a:srgbClr val="F3F4F6"/>
+                    </a:solidFill>
+                  </a:tcPr>
+                </a:tc>
+              </a:tr>
+            </a:tbl>
+          </a:graphicData>
+        </a:graphic>
+      </p:graphicFrame>
+      <p:sp>
+        <p:nvSpPr>
+          <p:cNvPr id="5" name="Text Box 4"/>
+          <p:cNvSpPr txBox="1"/>
+          <p:nvPr/>
+        </p:nvSpPr>
+        <p:spPr>
+          <a:xfrm>
+            <a:off x="0" y="6525260"/>
+            <a:ext cx="10992485" cy="306705"/>
+          </a:xfrm>
+          <a:prstGeom prst="rect">
+            <a:avLst/>
+          </a:prstGeom>
+          <a:noFill/>
+        </p:spPr>
+        <p:txBody>
+          <a:bodyPr wrap="square" rtlCol="0" anchor="t">
+            <a:spAutoFit/>
+          </a:bodyPr>
+          <a:p>
+            <a:r>
+              <a:rPr lang="en-US" altLang="en-US" sz="1400" b="1">
+                <a:solidFill>
+                  <a:srgbClr val="111827"/>
+                </a:solidFill>
+                <a:latin typeface="UCL Sans" pitchFamily="2" charset="77"/>
+                <a:sym typeface="+mn-ea"/>
+              </a:rPr>
+              <a:t>SMPC = Stochastic Model Predictive Control: a planning method that chooses safe actions while accounting for uncertainty.</a:t>
+            </a:r>
+            <a:endParaRPr lang="en-US" altLang="en-US" sz="1400" b="1">
+              <a:solidFill>
+                <a:srgbClr val="111827"/>
+              </a:solidFill>
+              <a:latin typeface="UCL Sans" pitchFamily="2" charset="77"/>
+              <a:sym typeface="+mn-ea"/>
             </a:endParaRPr>
           </a:p>
         </p:txBody>
@@ -15383,7 +16021,7 @@
                   </a:solidFill>
                   <a:latin typeface="UCL Sans" pitchFamily="2" charset="77"/>
                 </a:rPr>
-                <a:t>Failure condition:</a:t>
+                <a:t>Failure condition &amp; Alternative explanation:</a:t>
               </a:r>
               <a:endParaRPr lang="en-US" altLang="en-US" sz="1800" b="0">
                 <a:solidFill>
@@ -15456,7 +16094,12 @@
             <p:ph type="ctrTitle"/>
           </p:nvPr>
         </p:nvSpPr>
-        <p:spPr/>
+        <p:spPr>
+          <a:xfrm>
+            <a:off x="431800" y="409575"/>
+            <a:ext cx="10022205" cy="1009650"/>
+          </a:xfrm>
+        </p:spPr>
         <p:txBody>
           <a:bodyPr/>
           <a:lstStyle/>
@@ -15467,7 +16110,9 @@
               </a:rPr>
               <a:t>Execution plan</a:t>
             </a:r>
-            <a:endParaRPr lang="en-US"/>
+            <a:endParaRPr lang="en-US" altLang="en-US">
+              <a:latin typeface="UCL Sans SemiBold"/>
+            </a:endParaRPr>
           </a:p>
         </p:txBody>
       </p:sp>
@@ -15479,10 +16124,10 @@
         </p:nvGrpSpPr>
         <p:grpSpPr>
           <a:xfrm>
-            <a:off x="1331595" y="3593465"/>
-            <a:ext cx="10694950" cy="2301875"/>
-            <a:chOff x="687" y="5337"/>
-            <a:chExt cx="17119" cy="3625"/>
+            <a:off x="1053758" y="3306445"/>
+            <a:ext cx="11331562" cy="2558415"/>
+            <a:chOff x="-332" y="5337"/>
+            <a:chExt cx="18138" cy="4029"/>
           </a:xfrm>
         </p:grpSpPr>
         <p:grpSp>
@@ -15493,10 +16138,10 @@
           </p:nvGrpSpPr>
           <p:grpSpPr>
             <a:xfrm>
-              <a:off x="687" y="5337"/>
-              <a:ext cx="6834" cy="3322"/>
-              <a:chOff x="687" y="3824"/>
-              <a:chExt cx="6834" cy="3322"/>
+              <a:off x="-332" y="5337"/>
+              <a:ext cx="7622" cy="3322"/>
+              <a:chOff x="-332" y="3824"/>
+              <a:chExt cx="7622" cy="3322"/>
             </a:xfrm>
           </p:grpSpPr>
           <p:sp>
@@ -15507,8 +16152,8 @@
             </p:nvSpPr>
             <p:spPr>
               <a:xfrm>
-                <a:off x="687" y="4776"/>
-                <a:ext cx="6834" cy="2370"/>
+                <a:off x="-332" y="4776"/>
+                <a:ext cx="7622" cy="2370"/>
               </a:xfrm>
               <a:prstGeom prst="rect">
                 <a:avLst/>
@@ -15520,7 +16165,10 @@
                 <a:noAutofit/>
               </a:bodyPr>
               <a:p>
-                <a:pPr marL="285750" indent="-285750">
+                <a:pPr marL="285750" indent="-285750" latinLnBrk="0">
+                  <a:spcAft>
+                    <a:spcPts val="400"/>
+                  </a:spcAft>
                   <a:buFont typeface="Arial" panose="020B0604020202090204" pitchFamily="34" charset="0"/>
                   <a:buChar char="•"/>
                 </a:pPr>
@@ -15531,16 +16179,7 @@
                     </a:solidFill>
                     <a:latin typeface="UCL Sans" pitchFamily="2" charset="77"/>
                   </a:rPr>
-                  <a:t>No-TV baseline</a:t>
-                </a:r>
-                <a:r>
-                  <a:rPr lang="en-US" altLang="en-US" sz="1800">
-                    <a:solidFill>
-                      <a:srgbClr val="111827"/>
-                    </a:solidFill>
-                    <a:latin typeface="UCL Sans" pitchFamily="2" charset="77"/>
-                  </a:rPr>
-                  <a:t>s.</a:t>
+                  <a:t>No target-vehicle baselines.</a:t>
                 </a:r>
                 <a:endParaRPr lang="en-US" altLang="en-US" sz="1800">
                   <a:solidFill>
@@ -15550,7 +16189,10 @@
                 </a:endParaRPr>
               </a:p>
               <a:p>
-                <a:pPr marL="742950" lvl="1" indent="-285750">
+                <a:pPr marL="742950" lvl="1" indent="-285750" latinLnBrk="0">
+                  <a:spcAft>
+                    <a:spcPts val="400"/>
+                  </a:spcAft>
                   <a:buFont typeface="Arial" panose="020B0604020202090204" pitchFamily="34" charset="0"/>
                   <a:buChar char="•"/>
                 </a:pPr>
@@ -15571,7 +16213,10 @@
                 </a:endParaRPr>
               </a:p>
               <a:p>
-                <a:pPr marL="285750" indent="-285750">
+                <a:pPr marL="285750" indent="-285750" latinLnBrk="0">
+                  <a:spcAft>
+                    <a:spcPts val="400"/>
+                  </a:spcAft>
                   <a:buFont typeface="Arial" panose="020B0604020202090204" pitchFamily="34" charset="0"/>
                   <a:buChar char="•"/>
                 </a:pPr>
@@ -15593,7 +16238,10 @@
                 </a:endParaRPr>
               </a:p>
               <a:p>
-                <a:pPr marL="742950" lvl="1" indent="-285750">
+                <a:pPr marL="742950" lvl="1" indent="-285750" latinLnBrk="0">
+                  <a:spcAft>
+                    <a:spcPts val="400"/>
+                  </a:spcAft>
                   <a:buFont typeface="Arial" panose="020B0604020202090204" pitchFamily="34" charset="0"/>
                   <a:buChar char="•"/>
                 </a:pPr>
@@ -15615,7 +16263,10 @@
                 </a:endParaRPr>
               </a:p>
               <a:p>
-                <a:pPr marL="285750" indent="-285750">
+                <a:pPr marL="285750" indent="-285750" latinLnBrk="0">
+                  <a:spcAft>
+                    <a:spcPts val="400"/>
+                  </a:spcAft>
                   <a:buFont typeface="Arial" panose="020B0604020202090204" pitchFamily="34" charset="0"/>
                   <a:buChar char="•"/>
                 </a:pPr>
@@ -15636,7 +16287,10 @@
                 </a:endParaRPr>
               </a:p>
               <a:p>
-                <a:pPr marL="742950" lvl="1" indent="-285750">
+                <a:pPr marL="742950" lvl="1" indent="-285750" latinLnBrk="0">
+                  <a:spcAft>
+                    <a:spcPts val="400"/>
+                  </a:spcAft>
                   <a:buFont typeface="Arial" panose="020B0604020202090204" pitchFamily="34" charset="0"/>
                   <a:buChar char="•"/>
                 </a:pPr>
@@ -15647,7 +16301,7 @@
                     </a:solidFill>
                     <a:latin typeface="UCL Sans" pitchFamily="2" charset="77"/>
                   </a:rPr>
-                  <a:t>adaptive risk allocation</a:t>
+                  <a:t>adaptive risk-budget allocation</a:t>
                 </a:r>
                 <a:endParaRPr lang="en-US" altLang="en-US" sz="1800">
                   <a:solidFill>
@@ -15666,7 +16320,7 @@
             </p:nvSpPr>
             <p:spPr>
               <a:xfrm>
-                <a:off x="896" y="3824"/>
+                <a:off x="-123" y="3824"/>
                 <a:ext cx="5589" cy="792"/>
               </a:xfrm>
               <a:prstGeom prst="roundRect">
@@ -15783,7 +16437,7 @@
           <p:spPr>
             <a:xfrm>
               <a:off x="8206" y="6201"/>
-              <a:ext cx="9600" cy="2761"/>
+              <a:ext cx="9600" cy="3165"/>
             </a:xfrm>
             <a:prstGeom prst="rect">
               <a:avLst/>
@@ -15795,7 +16449,10 @@
               <a:spAutoFit/>
             </a:bodyPr>
             <a:p>
-              <a:pPr marL="285750" indent="-285750">
+              <a:pPr marL="285750" indent="-285750" latinLnBrk="0">
+                <a:spcAft>
+                  <a:spcPts val="400"/>
+                </a:spcAft>
                 <a:buFont typeface="Arial" panose="020B0604020202090204" pitchFamily="34" charset="0"/>
                 <a:buChar char="•"/>
               </a:pPr>
@@ -15816,7 +16473,10 @@
               </a:endParaRPr>
             </a:p>
             <a:p>
-              <a:pPr marL="285750" indent="-285750">
+              <a:pPr marL="285750" indent="-285750" latinLnBrk="0">
+                <a:spcAft>
+                  <a:spcPts val="400"/>
+                </a:spcAft>
                 <a:buFont typeface="Arial" panose="020B0604020202090204" pitchFamily="34" charset="0"/>
                 <a:buChar char="•"/>
               </a:pPr>
@@ -15837,7 +16497,10 @@
               </a:endParaRPr>
             </a:p>
             <a:p>
-              <a:pPr marL="285750" indent="-285750">
+              <a:pPr marL="285750" indent="-285750" latinLnBrk="0">
+                <a:spcAft>
+                  <a:spcPts val="400"/>
+                </a:spcAft>
                 <a:buFont typeface="Arial" panose="020B0604020202090204" pitchFamily="34" charset="0"/>
                 <a:buChar char="•"/>
               </a:pPr>
@@ -15858,7 +16521,10 @@
               </a:endParaRPr>
             </a:p>
             <a:p>
-              <a:pPr marL="285750" indent="-285750">
+              <a:pPr marL="285750" indent="-285750" latinLnBrk="0">
+                <a:spcAft>
+                  <a:spcPts val="400"/>
+                </a:spcAft>
                 <a:buFont typeface="Arial" panose="020B0604020202090204" pitchFamily="34" charset="0"/>
                 <a:buChar char="•"/>
               </a:pPr>
@@ -15879,7 +16545,10 @@
               </a:endParaRPr>
             </a:p>
             <a:p>
-              <a:pPr marL="285750" indent="-285750">
+              <a:pPr marL="285750" indent="-285750" latinLnBrk="0">
+                <a:spcAft>
+                  <a:spcPts val="400"/>
+                </a:spcAft>
                 <a:buFont typeface="Arial" panose="020B0604020202090204" pitchFamily="34" charset="0"/>
                 <a:buChar char="•"/>
               </a:pPr>
@@ -15900,7 +16569,10 @@
               </a:endParaRPr>
             </a:p>
             <a:p>
-              <a:pPr marL="285750" indent="-285750">
+              <a:pPr marL="285750" indent="-285750" latinLnBrk="0">
+                <a:spcAft>
+                  <a:spcPts val="400"/>
+                </a:spcAft>
                 <a:buFont typeface="Arial" panose="020B0604020202090204" pitchFamily="34" charset="0"/>
                 <a:buChar char="•"/>
               </a:pPr>
@@ -15911,7 +16583,7 @@
                   </a:solidFill>
                   <a:latin typeface="UCL Sans" pitchFamily="2" charset="77"/>
                 </a:rPr>
-                <a:t>Solve time.</a:t>
+                <a:t>Computation time.</a:t>
               </a:r>
               <a:endParaRPr lang="en-US" altLang="en-US" sz="1800">
                 <a:solidFill>
@@ -15939,7 +16611,7 @@
         </p:blipFill>
         <p:spPr>
           <a:xfrm>
-            <a:off x="341630" y="1430655"/>
+            <a:off x="341630" y="1287145"/>
             <a:ext cx="11469370" cy="1636395"/>
           </a:xfrm>
           <a:prstGeom prst="rect">
@@ -15985,7 +16657,7 @@
                 <a:latin typeface="UCL Sans" pitchFamily="2" charset="77"/>
                 <a:sym typeface="+mn-ea"/>
               </a:rPr>
-              <a:t>GMM: represents possible target-vehicle futures using probabilities and uncertainty.</a:t>
+              <a:t>GMM = Gaussian Mixture Model. It represents several possible target-vehicle trajectories and their probabilities.</a:t>
             </a:r>
             <a:endParaRPr lang="en-US" altLang="en-US" sz="1400">
               <a:solidFill>
@@ -16013,7 +16685,7 @@
                 <a:latin typeface="UCL Sans" pitchFamily="2" charset="77"/>
                 <a:sym typeface="+mn-ea"/>
               </a:rPr>
-              <a:t>SMPC: a planning method that chooses safe actions while accounting for uncertain future paths.</a:t>
+              <a:t>SMPC = Stochastic Model Predictive Control. It chooses actions using probabilistic safety constraints.</a:t>
             </a:r>
             <a:endParaRPr lang="en-US" altLang="en-US" sz="1400">
               <a:solidFill>
@@ -16056,7 +16728,7 @@
         <p:spPr>
           <a:xfrm>
             <a:off x="431800" y="409575"/>
-            <a:ext cx="7550785" cy="838835"/>
+            <a:ext cx="10343515" cy="838835"/>
           </a:xfrm>
         </p:spPr>
         <p:txBody>
@@ -16069,13 +16741,30 @@
               </a:rPr>
               <a:t>Execution plan</a:t>
             </a:r>
-            <a:endParaRPr lang="en-US"/>
+            <a:r>
+              <a:rPr lang="en-US" altLang="en-GB">
+                <a:latin typeface="UCL Sans SemiBold"/>
+                <a:sym typeface="+mn-ea"/>
+              </a:rPr>
+              <a:t>: </a:t>
+            </a:r>
+            <a:r>
+              <a:rPr lang="en-US" altLang="en-US">
+                <a:latin typeface="UCL Sans SemiBold"/>
+                <a:sym typeface="+mn-ea"/>
+              </a:rPr>
+              <a:t>Timeline and Dependencies</a:t>
+            </a:r>
+            <a:endParaRPr lang="en-US" altLang="en-US">
+              <a:latin typeface="UCL Sans SemiBold"/>
+              <a:sym typeface="+mn-ea"/>
+            </a:endParaRPr>
           </a:p>
         </p:txBody>
       </p:sp>
       <p:pic>
         <p:nvPicPr>
-          <p:cNvPr id="22" name="Picture 21"/>
+          <p:cNvPr id="4" name="Picture 3"/>
           <p:cNvPicPr>
             <a:picLocks noChangeAspect="1"/>
           </p:cNvPicPr>
@@ -16089,8 +16778,8 @@
         </p:blipFill>
         <p:spPr>
           <a:xfrm>
-            <a:off x="198120" y="1449070"/>
-            <a:ext cx="11729085" cy="4269105"/>
+            <a:off x="911225" y="1187450"/>
+            <a:ext cx="10049510" cy="4826635"/>
           </a:xfrm>
           <a:prstGeom prst="rect">
             <a:avLst/>
@@ -17226,8 +17915,8 @@
 </file>
 
 <file path=customXml/item1.xml><?xml version="1.0" encoding="utf-8"?>
-<ct:contentTypeSchema xmlns:ma="http://schemas.microsoft.com/office/2006/metadata/properties/metaAttributes" xmlns:ct="http://schemas.microsoft.com/office/2006/metadata/contentType" ma:contentTypeName="Document" ct:_="" ma:_="" ma:versionID="601ee87aba0edee35dd0bd1031319f69" ma:contentTypeID="0x010100A12A0662030DBC4F99C1FA9D93D14A4C" ma:contentTypeVersion="" ma:contentTypeDescription="Create a new document." ma:contentTypeScope="">
-  <xsd:schema xmlns:xsd="http://www.w3.org/2001/XMLSchema" xmlns:xs="http://www.w3.org/2001/XMLSchema" xmlns:ns2="1d368349-1023-48e7-96c9-f9d028f6f0fb" xmlns:ns3="1aa119c2-5735-4356-91ec-0ca074bf9097" xmlns:p="http://schemas.microsoft.com/office/2006/metadata/properties" xmlns:ns4="32f397aa-99c0-43f4-9b94-7b5d785faf95" ns3:_="" ma:root="true" ma:fieldsID="ceaa2ff74debb88eeec5ab219e85c5f9" ns2:_="" ns4:_="" targetNamespace="http://schemas.microsoft.com/office/2006/metadata/properties">
+<ct:contentTypeSchema xmlns:ct="http://schemas.microsoft.com/office/2006/metadata/contentType" xmlns:ma="http://schemas.microsoft.com/office/2006/metadata/properties/metaAttributes" ma:contentTypeVersion="" ma:contentTypeDescription="Create a new document." ct:_="" ma:_="" ma:contentTypeID="0x010100A12A0662030DBC4F99C1FA9D93D14A4C" ma:contentTypeScope="" ma:contentTypeName="Document" ma:versionID="601ee87aba0edee35dd0bd1031319f69">
+  <xsd:schema xmlns:p="http://schemas.microsoft.com/office/2006/metadata/properties" xmlns:xs="http://www.w3.org/2001/XMLSchema" xmlns:ns2="1d368349-1023-48e7-96c9-f9d028f6f0fb" xmlns:ns3="1aa119c2-5735-4356-91ec-0ca074bf9097" xmlns:ns4="32f397aa-99c0-43f4-9b94-7b5d785faf95" xmlns:xsd="http://www.w3.org/2001/XMLSchema" ns2:_="" ns4:_="" targetNamespace="http://schemas.microsoft.com/office/2006/metadata/properties" ma:root="true" ns3:_="" ma:fieldsID="ceaa2ff74debb88eeec5ab219e85c5f9">
     <xsd:import namespace="1d368349-1023-48e7-96c9-f9d028f6f0fb"/>
     <xsd:import namespace="1aa119c2-5735-4356-91ec-0ca074bf9097"/>
     <xsd:import namespace="32f397aa-99c0-43f4-9b94-7b5d785faf95"/>
@@ -17261,95 +17950,95 @@
       </xsd:complexType>
     </xsd:element>
   </xsd:schema>
-  <xsd:schema xmlns:xsd="http://www.w3.org/2001/XMLSchema" xmlns:xs="http://www.w3.org/2001/XMLSchema" xmlns:dms="http://schemas.microsoft.com/office/2006/documentManagement/types" xmlns:pc="http://schemas.microsoft.com/office/infopath/2007/PartnerControls" elementFormDefault="qualified" targetNamespace="1d368349-1023-48e7-96c9-f9d028f6f0fb">
+  <xsd:schema xmlns:dms="http://schemas.microsoft.com/office/2006/documentManagement/types" xmlns:xs="http://www.w3.org/2001/XMLSchema" xmlns:xsd="http://www.w3.org/2001/XMLSchema" xmlns:pc="http://schemas.microsoft.com/office/infopath/2007/PartnerControls" targetNamespace="1d368349-1023-48e7-96c9-f9d028f6f0fb" elementFormDefault="qualified">
     <xsd:import namespace="http://schemas.microsoft.com/office/2006/documentManagement/types"/>
     <xsd:import namespace="http://schemas.microsoft.com/office/infopath/2007/PartnerControls"/>
-    <xsd:element name="MediaServiceMetadata" ma:internalName="MediaServiceMetadata" ma:readOnly="true" nillable="true" ma:index="8" ma:hidden="true" ma:displayName="MediaServiceMetadata">
+    <xsd:element name="MediaServiceMetadata" ma:hidden="true" ma:displayName="MediaServiceMetadata" nillable="true" ma:internalName="MediaServiceMetadata" ma:readOnly="true" ma:index="8">
       <xsd:simpleType>
         <xsd:restriction base="dms:Note"/>
       </xsd:simpleType>
     </xsd:element>
-    <xsd:element name="MediaServiceFastMetadata" ma:internalName="MediaServiceFastMetadata" ma:readOnly="true" nillable="true" ma:index="9" ma:hidden="true" ma:displayName="MediaServiceFastMetadata">
+    <xsd:element name="MediaServiceFastMetadata" ma:hidden="true" ma:displayName="MediaServiceFastMetadata" nillable="true" ma:internalName="MediaServiceFastMetadata" ma:readOnly="true" ma:index="9">
       <xsd:simpleType>
         <xsd:restriction base="dms:Note"/>
       </xsd:simpleType>
     </xsd:element>
-    <xsd:element name="MediaServiceAutoKeyPoints" ma:internalName="MediaServiceAutoKeyPoints" ma:readOnly="true" nillable="true" ma:index="10" ma:hidden="true" ma:displayName="MediaServiceAutoKeyPoints">
+    <xsd:element name="MediaServiceAutoKeyPoints" ma:hidden="true" ma:displayName="MediaServiceAutoKeyPoints" nillable="true" ma:internalName="MediaServiceAutoKeyPoints" ma:readOnly="true" ma:index="10">
       <xsd:simpleType>
         <xsd:restriction base="dms:Note"/>
       </xsd:simpleType>
     </xsd:element>
-    <xsd:element name="MediaServiceKeyPoints" ma:internalName="MediaServiceKeyPoints" ma:readOnly="true" nillable="true" ma:index="11" ma:displayName="KeyPoints">
+    <xsd:element name="MediaServiceKeyPoints" ma:displayName="KeyPoints" nillable="true" ma:internalName="MediaServiceKeyPoints" ma:readOnly="true" ma:index="11">
       <xsd:simpleType>
         <xsd:restriction base="dms:Note">
           <xsd:maxLength value="255"/>
         </xsd:restriction>
       </xsd:simpleType>
     </xsd:element>
-    <xsd:element name="MediaServiceAutoTags" ma:internalName="MediaServiceAutoTags" ma:readOnly="true" nillable="true" ma:index="12" ma:displayName="Tags">
+    <xsd:element name="MediaServiceAutoTags" ma:displayName="Tags" nillable="true" ma:internalName="MediaServiceAutoTags" ma:readOnly="true" ma:index="12">
       <xsd:simpleType>
         <xsd:restriction base="dms:Text"/>
       </xsd:simpleType>
     </xsd:element>
-    <xsd:element name="MediaServiceOCR" ma:internalName="MediaServiceOCR" ma:readOnly="true" nillable="true" ma:index="13" ma:displayName="Extracted Text">
+    <xsd:element name="MediaServiceOCR" ma:displayName="Extracted Text" nillable="true" ma:internalName="MediaServiceOCR" ma:readOnly="true" ma:index="13">
       <xsd:simpleType>
         <xsd:restriction base="dms:Note">
           <xsd:maxLength value="255"/>
         </xsd:restriction>
       </xsd:simpleType>
     </xsd:element>
-    <xsd:element name="MediaServiceGenerationTime" ma:internalName="MediaServiceGenerationTime" ma:readOnly="true" nillable="true" ma:index="14" ma:hidden="true" ma:displayName="MediaServiceGenerationTime">
+    <xsd:element name="MediaServiceGenerationTime" ma:hidden="true" ma:displayName="MediaServiceGenerationTime" nillable="true" ma:internalName="MediaServiceGenerationTime" ma:readOnly="true" ma:index="14">
       <xsd:simpleType>
         <xsd:restriction base="dms:Text"/>
       </xsd:simpleType>
     </xsd:element>
-    <xsd:element name="MediaServiceEventHashCode" ma:internalName="MediaServiceEventHashCode" ma:readOnly="true" nillable="true" ma:index="15" ma:hidden="true" ma:displayName="MediaServiceEventHashCode">
+    <xsd:element name="MediaServiceEventHashCode" ma:hidden="true" ma:displayName="MediaServiceEventHashCode" nillable="true" ma:internalName="MediaServiceEventHashCode" ma:readOnly="true" ma:index="15">
       <xsd:simpleType>
         <xsd:restriction base="dms:Text"/>
       </xsd:simpleType>
     </xsd:element>
-    <xsd:element name="MediaServiceDateTaken" ma:internalName="MediaServiceDateTaken" ma:readOnly="true" nillable="true" ma:index="16" ma:hidden="true" ma:displayName="MediaServiceDateTaken">
+    <xsd:element name="MediaServiceDateTaken" ma:hidden="true" ma:displayName="MediaServiceDateTaken" nillable="true" ma:internalName="MediaServiceDateTaken" ma:readOnly="true" ma:index="16">
       <xsd:simpleType>
         <xsd:restriction base="dms:Text"/>
       </xsd:simpleType>
     </xsd:element>
-    <xsd:element name="MediaServiceLocation" ma:internalName="MediaServiceLocation" ma:readOnly="true" nillable="true" ma:index="19" ma:displayName="Location">
+    <xsd:element name="MediaServiceLocation" ma:displayName="Location" nillable="true" ma:internalName="MediaServiceLocation" ma:readOnly="true" ma:index="19">
       <xsd:simpleType>
         <xsd:restriction base="dms:Text"/>
       </xsd:simpleType>
     </xsd:element>
-    <xsd:element name="MediaLengthInSeconds" ma:internalName="MediaLengthInSeconds" ma:readOnly="true" nillable="true" ma:index="20" ma:hidden="true" ma:displayName="MediaLengthInSeconds">
+    <xsd:element name="MediaLengthInSeconds" ma:hidden="true" ma:displayName="MediaLengthInSeconds" nillable="true" ma:internalName="MediaLengthInSeconds" ma:readOnly="true" ma:index="20">
       <xsd:simpleType>
         <xsd:restriction base="dms:Unknown"/>
       </xsd:simpleType>
     </xsd:element>
-    <xsd:element ma:termSetId="09814cd3-568e-fe90-9814-8d621ff8fb84" ma:taxonomyMulti="true" name="lcf76f155ced4ddcb4097134ff3c332f" ma:anchorId="fba54fb3-c3e1-fe81-a776-ca4b69148c4d" ma:internalName="lcf76f155ced4ddcb4097134ff3c332f" ma:fieldId="{5cf76f15-5ced-4ddc-b409-7134ff3c332f}" ma:readOnly="false" nillable="true" ma:sspId="579a89b1-2c2c-4f7f-9bd7-7914fb13a02b" ma:taxonomy="true" ma:index="22" ma:isKeyword="false" ma:open="true" ma:taxonomyFieldName="MediaServiceImageTags" ma:displayName="Image Tags">
+    <xsd:element ma:open="true" name="lcf76f155ced4ddcb4097134ff3c332f" ma:taxonomy="true" ma:isKeyword="false" ma:termSetId="09814cd3-568e-fe90-9814-8d621ff8fb84" ma:fieldId="{5cf76f15-5ced-4ddc-b409-7134ff3c332f}" ma:displayName="Image Tags" nillable="true" ma:sspId="579a89b1-2c2c-4f7f-9bd7-7914fb13a02b" ma:taxonomyFieldName="MediaServiceImageTags" ma:taxonomyMulti="true" ma:anchorId="fba54fb3-c3e1-fe81-a776-ca4b69148c4d" ma:internalName="lcf76f155ced4ddcb4097134ff3c332f" ma:readOnly="false" ma:index="22">
       <xsd:complexType>
         <xsd:sequence>
-          <xsd:element maxOccurs="1" minOccurs="0" ref="pc:Terms"/>
+          <xsd:element minOccurs="0" ref="pc:Terms" maxOccurs="1"/>
         </xsd:sequence>
       </xsd:complexType>
     </xsd:element>
-    <xsd:element name="MediaServiceObjectDetectorVersions" ma:internalName="MediaServiceObjectDetectorVersions" ma:readOnly="true" ma:indexed="true" nillable="true" ma:index="24" ma:hidden="true" ma:displayName="MediaServiceObjectDetectorVersions">
+    <xsd:element name="MediaServiceObjectDetectorVersions" ma:indexed="true" ma:hidden="true" ma:displayName="MediaServiceObjectDetectorVersions" nillable="true" ma:internalName="MediaServiceObjectDetectorVersions" ma:readOnly="true" ma:index="24">
       <xsd:simpleType>
         <xsd:restriction base="dms:Text"/>
       </xsd:simpleType>
     </xsd:element>
-    <xsd:element name="MediaServiceSearchProperties" ma:internalName="MediaServiceSearchProperties" ma:readOnly="true" nillable="true" ma:index="25" ma:hidden="true" ma:displayName="MediaServiceSearchProperties">
+    <xsd:element name="MediaServiceSearchProperties" ma:hidden="true" ma:displayName="MediaServiceSearchProperties" nillable="true" ma:internalName="MediaServiceSearchProperties" ma:readOnly="true" ma:index="25">
       <xsd:simpleType>
         <xsd:restriction base="dms:Note"/>
       </xsd:simpleType>
     </xsd:element>
   </xsd:schema>
-  <xsd:schema xmlns:xsd="http://www.w3.org/2001/XMLSchema" xmlns:xs="http://www.w3.org/2001/XMLSchema" xmlns:dms="http://schemas.microsoft.com/office/2006/documentManagement/types" xmlns:pc="http://schemas.microsoft.com/office/infopath/2007/PartnerControls" elementFormDefault="qualified" targetNamespace="1aa119c2-5735-4356-91ec-0ca074bf9097">
+  <xsd:schema xmlns:dms="http://schemas.microsoft.com/office/2006/documentManagement/types" xmlns:xs="http://www.w3.org/2001/XMLSchema" xmlns:xsd="http://www.w3.org/2001/XMLSchema" xmlns:pc="http://schemas.microsoft.com/office/infopath/2007/PartnerControls" targetNamespace="1aa119c2-5735-4356-91ec-0ca074bf9097" elementFormDefault="qualified">
     <xsd:import namespace="http://schemas.microsoft.com/office/2006/documentManagement/types"/>
     <xsd:import namespace="http://schemas.microsoft.com/office/infopath/2007/PartnerControls"/>
-    <xsd:element name="SharedWithUsers" ma:internalName="SharedWithUsers" ma:readOnly="true" nillable="true" ma:index="17" ma:displayName="Shared With">
+    <xsd:element name="SharedWithUsers" ma:displayName="Shared With" nillable="true" ma:internalName="SharedWithUsers" ma:readOnly="true" ma:index="17">
       <xsd:complexType>
         <xsd:complexContent>
           <xsd:extension base="dms:UserMulti">
             <xsd:sequence>
-              <xsd:element maxOccurs="unbounded" minOccurs="0" name="UserInfo">
+              <xsd:element minOccurs="0" name="UserInfo" maxOccurs="unbounded">
                 <xsd:complexType>
                   <xsd:sequence>
                     <xsd:element minOccurs="0" name="DisplayName" type="xsd:string"/>
@@ -17363,7 +18052,7 @@
         </xsd:complexContent>
       </xsd:complexType>
     </xsd:element>
-    <xsd:element name="SharedWithDetails" ma:internalName="SharedWithDetails" ma:readOnly="true" nillable="true" ma:index="18" ma:displayName="Shared With Details">
+    <xsd:element name="SharedWithDetails" ma:displayName="Shared With Details" nillable="true" ma:internalName="SharedWithDetails" ma:readOnly="true" ma:index="18">
       <xsd:simpleType>
         <xsd:restriction base="dms:Note">
           <xsd:maxLength value="255"/>
@@ -17371,52 +18060,52 @@
       </xsd:simpleType>
     </xsd:element>
   </xsd:schema>
-  <xsd:schema xmlns:xsd="http://www.w3.org/2001/XMLSchema" xmlns:xs="http://www.w3.org/2001/XMLSchema" xmlns:dms="http://schemas.microsoft.com/office/2006/documentManagement/types" xmlns:pc="http://schemas.microsoft.com/office/infopath/2007/PartnerControls" elementFormDefault="qualified" targetNamespace="32f397aa-99c0-43f4-9b94-7b5d785faf95">
+  <xsd:schema xmlns:dms="http://schemas.microsoft.com/office/2006/documentManagement/types" xmlns:xs="http://www.w3.org/2001/XMLSchema" xmlns:xsd="http://www.w3.org/2001/XMLSchema" xmlns:pc="http://schemas.microsoft.com/office/infopath/2007/PartnerControls" targetNamespace="32f397aa-99c0-43f4-9b94-7b5d785faf95" elementFormDefault="qualified">
     <xsd:import namespace="http://schemas.microsoft.com/office/2006/documentManagement/types"/>
     <xsd:import namespace="http://schemas.microsoft.com/office/infopath/2007/PartnerControls"/>
-    <xsd:element name="TaxCatchAll" ma:internalName="TaxCatchAll" nillable="true" ma:index="23" ma:web="32f397aa-99c0-43f4-9b94-7b5d785faf95" ma:showField="CatchAllData" ma:list="{d117ceb8-fbd8-4cd5-a93e-9fc1393353fc}" ma:hidden="true" ma:displayName="Taxonomy Catch All Column">
+    <xsd:element ma:showField="CatchAllData" name="TaxCatchAll" ma:hidden="true" ma:displayName="Taxonomy Catch All Column" nillable="true" ma:web="32f397aa-99c0-43f4-9b94-7b5d785faf95" ma:internalName="TaxCatchAll" ma:index="23" ma:list="{d117ceb8-fbd8-4cd5-a93e-9fc1393353fc}">
       <xsd:complexType>
         <xsd:complexContent>
           <xsd:extension base="dms:MultiChoiceLookup">
             <xsd:sequence>
-              <xsd:element maxOccurs="unbounded" minOccurs="0" name="Value" nillable="true" type="dms:Lookup"/>
+              <xsd:element minOccurs="0" name="Value" nillable="true" type="dms:Lookup" maxOccurs="unbounded"/>
             </xsd:sequence>
           </xsd:extension>
         </xsd:complexContent>
       </xsd:complexType>
     </xsd:element>
   </xsd:schema>
-  <xsd:schema xmlns:xsd="http://www.w3.org/2001/XMLSchema" xmlns:xsi="http://www.w3.org/2001/XMLSchema-instance" xmlns="http://schemas.openxmlformats.org/package/2006/metadata/core-properties" xmlns:dcterms="http://purl.org/dc/terms/" xmlns:odoc="http://schemas.microsoft.com/internal/obd" xmlns:dc="http://purl.org/dc/elements/1.1/" elementFormDefault="qualified" attributeFormDefault="unqualified" targetNamespace="http://schemas.openxmlformats.org/package/2006/metadata/core-properties" blockDefault="#all">
-    <xsd:import namespace="http://purl.org/dc/elements/1.1/" schemaLocation="http://dublincore.org/schemas/xmls/qdc/2003/04/02/dc.xsd"/>
-    <xsd:import namespace="http://purl.org/dc/terms/" schemaLocation="http://dublincore.org/schemas/xmls/qdc/2003/04/02/dcterms.xsd"/>
+  <xsd:schema xmlns="http://schemas.openxmlformats.org/package/2006/metadata/core-properties" xmlns:dc="http://purl.org/dc/elements/1.1/" xmlns:xsi="http://www.w3.org/2001/XMLSchema-instance" xmlns:dcterms="http://purl.org/dc/terms/" xmlns:odoc="http://schemas.microsoft.com/internal/obd" xmlns:xsd="http://www.w3.org/2001/XMLSchema" blockDefault="#all" targetNamespace="http://schemas.openxmlformats.org/package/2006/metadata/core-properties" attributeFormDefault="unqualified" elementFormDefault="qualified">
+    <xsd:import schemaLocation="http://dublincore.org/schemas/xmls/qdc/2003/04/02/dc.xsd" namespace="http://purl.org/dc/elements/1.1/"/>
+    <xsd:import schemaLocation="http://dublincore.org/schemas/xmls/qdc/2003/04/02/dcterms.xsd" namespace="http://purl.org/dc/terms/"/>
     <xsd:element name="coreProperties" type="CT_coreProperties"/>
     <xsd:complexType name="CT_coreProperties">
       <xsd:all>
-        <xsd:element maxOccurs="1" minOccurs="0" ref="dc:creator"/>
-        <xsd:element maxOccurs="1" minOccurs="0" ref="dcterms:created"/>
-        <xsd:element maxOccurs="1" minOccurs="0" ref="dc:identifier"/>
-        <xsd:element maxOccurs="1" minOccurs="0" name="contentType" ma:index="0" type="xsd:string" ma:displayName="Content Type"/>
-        <xsd:element maxOccurs="1" minOccurs="0" ma:index="4" ref="dc:title" ma:displayName="Title"/>
-        <xsd:element maxOccurs="1" minOccurs="0" ref="dc:subject"/>
-        <xsd:element maxOccurs="1" minOccurs="0" ref="dc:description"/>
-        <xsd:element maxOccurs="1" minOccurs="0" name="keywords" type="xsd:string"/>
-        <xsd:element maxOccurs="1" minOccurs="0" ref="dc:language"/>
-        <xsd:element maxOccurs="1" minOccurs="0" name="category" type="xsd:string"/>
-        <xsd:element maxOccurs="1" minOccurs="0" name="version" type="xsd:string"/>
-        <xsd:element maxOccurs="1" minOccurs="0" name="revision" type="xsd:string">
+        <xsd:element minOccurs="0" ref="dc:creator" maxOccurs="1"/>
+        <xsd:element minOccurs="0" ref="dcterms:created" maxOccurs="1"/>
+        <xsd:element minOccurs="0" ref="dc:identifier" maxOccurs="1"/>
+        <xsd:element minOccurs="0" name="contentType" ma:displayName="Content Type" type="xsd:string" maxOccurs="1" ma:index="0"/>
+        <xsd:element minOccurs="0" ref="dc:title" ma:displayName="Title" maxOccurs="1" ma:index="4"/>
+        <xsd:element minOccurs="0" ref="dc:subject" maxOccurs="1"/>
+        <xsd:element minOccurs="0" ref="dc:description" maxOccurs="1"/>
+        <xsd:element minOccurs="0" name="keywords" type="xsd:string" maxOccurs="1"/>
+        <xsd:element minOccurs="0" ref="dc:language" maxOccurs="1"/>
+        <xsd:element minOccurs="0" name="category" type="xsd:string" maxOccurs="1"/>
+        <xsd:element minOccurs="0" name="version" type="xsd:string" maxOccurs="1"/>
+        <xsd:element minOccurs="0" name="revision" type="xsd:string" maxOccurs="1">
           <xsd:annotation>
             <xsd:documentation>
                         This value indicates the number of saves or revisions. The application is responsible for updating this value after each revision.
                     </xsd:documentation>
           </xsd:annotation>
         </xsd:element>
-        <xsd:element maxOccurs="1" minOccurs="0" name="lastModifiedBy" type="xsd:string"/>
-        <xsd:element maxOccurs="1" minOccurs="0" ref="dcterms:modified"/>
-        <xsd:element maxOccurs="1" minOccurs="0" name="contentStatus" type="xsd:string"/>
+        <xsd:element minOccurs="0" name="lastModifiedBy" type="xsd:string" maxOccurs="1"/>
+        <xsd:element minOccurs="0" ref="dcterms:modified" maxOccurs="1"/>
+        <xsd:element minOccurs="0" name="contentStatus" type="xsd:string" maxOccurs="1"/>
       </xsd:all>
     </xsd:complexType>
   </xsd:schema>
-  <xs:schema xmlns:xs="http://www.w3.org/2001/XMLSchema" xmlns:pc="http://schemas.microsoft.com/office/infopath/2007/PartnerControls" elementFormDefault="qualified" attributeFormDefault="unqualified" targetNamespace="http://schemas.microsoft.com/office/infopath/2007/PartnerControls">
+  <xs:schema xmlns:xs="http://www.w3.org/2001/XMLSchema" xmlns:pc="http://schemas.microsoft.com/office/infopath/2007/PartnerControls" targetNamespace="http://schemas.microsoft.com/office/infopath/2007/PartnerControls" attributeFormDefault="unqualified" elementFormDefault="qualified">
     <xs:element name="Person">
       <xs:complexType>
         <xs:sequence>
@@ -17432,7 +18121,7 @@
     <xs:element name="BDCAssociatedEntity">
       <xs:complexType>
         <xs:sequence>
-          <xs:element maxOccurs="unbounded" minOccurs="0" ref="pc:BDCEntity"/>
+          <xs:element minOccurs="0" ref="pc:BDCEntity" maxOccurs="unbounded"/>
         </xs:sequence>
         <xs:attribute ref="pc:EntityNamespace"/>
         <xs:attribute ref="pc:EntityName"/>
@@ -17467,7 +18156,7 @@
     <xs:element name="Terms">
       <xs:complexType>
         <xs:sequence>
-          <xs:element maxOccurs="unbounded" minOccurs="0" ref="pc:TermInfo"/>
+          <xs:element minOccurs="0" ref="pc:TermInfo" maxOccurs="unbounded"/>
         </xs:sequence>
       </xs:complexType>
     </xs:element>
@@ -17486,7 +18175,7 @@
 </file>
 
 <file path=customXml/item2.xml><?xml version="1.0" encoding="utf-8"?>
-<p:properties xmlns:xsi="http://www.w3.org/2001/XMLSchema-instance" xmlns:pc="http://schemas.microsoft.com/office/infopath/2007/PartnerControls" xmlns:p="http://schemas.microsoft.com/office/2006/metadata/properties">
+<p:properties xmlns:xsi="http://www.w3.org/2001/XMLSchema-instance" xmlns:p="http://schemas.microsoft.com/office/2006/metadata/properties" xmlns:pc="http://schemas.microsoft.com/office/infopath/2007/PartnerControls">
   <documentManagement>
     <lcf76f155ced4ddcb4097134ff3c332f xmlns="1d368349-1023-48e7-96c9-f9d028f6f0fb">
       <Terms xmlns="http://schemas.microsoft.com/office/infopath/2007/PartnerControls"/>

</xml_diff>